<commit_message>
docs: fix capability wording in project status slide
Co-authored-by: plusand <alwaysneedlearn@users.noreply.github.com>
</commit_message>
<xml_diff>
--- a/docs/slides/semaphore_project_status.pptx
+++ b/docs/slides/semaphore_project_status.pptx
@@ -3196,7 +3196,7 @@
                 </a:solidFill>
                 <a:latin typeface="Calibri"/>
               </a:rPr>
-              <a:t>Go Backend + Vue.js 2 Frontend  ·  Ansible Playbooks (WinRM)  ·  TDengine 时序数据  ·  7 设备类型</a:t>
+              <a:t>Go Backend + Vue.js 2 Frontend  ·  Ansible Playbooks (WinRM)  ·  当前设备列表 UI：巡检 / 重发 / 重启 / 重部署</a:t>
             </a:r>
           </a:p>
         </p:txBody>
@@ -3930,7 +3930,7 @@
                           </a:solidFill>
                           <a:latin typeface="Calibri"/>
                         </a:rPr>
-                        <a:t>启停</a:t>
+                        <a:t>当前 UI 操作</a:t>
                       </a:r>
                     </a:p>
                   </a:txBody>
@@ -4043,11 +4043,11 @@
                       <a:r>
                         <a:rPr sz="750" b="0">
                           <a:solidFill>
-                            <a:srgbClr val="1A8A4A"/>
-                          </a:solidFill>
-                          <a:latin typeface="Calibri"/>
-                        </a:rPr>
-                        <a:t>✓ 杀 / 任务</a:t>
+                            <a:srgbClr val="1A1A2E"/>
+                          </a:solidFill>
+                          <a:latin typeface="Calibri"/>
+                        </a:rPr>
+                        <a:t>巡检 / 重启 / 重部署</a:t>
                       </a:r>
                     </a:p>
                   </a:txBody>
@@ -4160,11 +4160,11 @@
                       <a:r>
                         <a:rPr sz="750" b="0">
                           <a:solidFill>
-                            <a:srgbClr val="1A8A4A"/>
-                          </a:solidFill>
-                          <a:latin typeface="Calibri"/>
-                        </a:rPr>
-                        <a:t>✓ 优雅 / 任务</a:t>
+                            <a:srgbClr val="1A1A2E"/>
+                          </a:solidFill>
+                          <a:latin typeface="Calibri"/>
+                        </a:rPr>
+                        <a:t>巡检 / 重启 / 重部署</a:t>
                       </a:r>
                     </a:p>
                   </a:txBody>
@@ -4281,7 +4281,7 @@
                           </a:solidFill>
                           <a:latin typeface="Calibri"/>
                         </a:rPr>
-                        <a:t>Ensure 启动</a:t>
+                        <a:t>巡检 / 重发</a:t>
                       </a:r>
                     </a:p>
                   </a:txBody>
@@ -4394,11 +4394,11 @@
                       <a:r>
                         <a:rPr sz="750" b="0">
                           <a:solidFill>
-                            <a:srgbClr val="1A8A4A"/>
-                          </a:solidFill>
-                          <a:latin typeface="Calibri"/>
-                        </a:rPr>
-                        <a:t>✓ 强杀 / 任务</a:t>
+                            <a:srgbClr val="1A1A2E"/>
+                          </a:solidFill>
+                          <a:latin typeface="Calibri"/>
+                        </a:rPr>
+                        <a:t>巡检 / 重启 / 重部署</a:t>
                       </a:r>
                     </a:p>
                   </a:txBody>
@@ -4511,11 +4511,11 @@
                       <a:r>
                         <a:rPr sz="750" b="0">
                           <a:solidFill>
-                            <a:srgbClr val="1A8A4A"/>
-                          </a:solidFill>
-                          <a:latin typeface="Calibri"/>
-                        </a:rPr>
-                        <a:t>✓ 服务控制</a:t>
+                            <a:srgbClr val="1A1A2E"/>
+                          </a:solidFill>
+                          <a:latin typeface="Calibri"/>
+                        </a:rPr>
+                        <a:t>巡检 / 重启 / 重部署</a:t>
                       </a:r>
                     </a:p>
                   </a:txBody>
@@ -4632,7 +4632,7 @@
                           </a:solidFill>
                           <a:latin typeface="Calibri"/>
                         </a:rPr>
-                        <a:t>—</a:t>
+                        <a:t>仅重发</a:t>
                       </a:r>
                     </a:p>
                   </a:txBody>
@@ -4745,11 +4745,11 @@
                       <a:r>
                         <a:rPr sz="750" b="0">
                           <a:solidFill>
-                            <a:srgbClr val="1A8A4A"/>
-                          </a:solidFill>
-                          <a:latin typeface="Calibri"/>
-                        </a:rPr>
-                        <a:t>✓ 优雅 / 任务</a:t>
+                            <a:srgbClr val="1A1A2E"/>
+                          </a:solidFill>
+                          <a:latin typeface="Calibri"/>
+                        </a:rPr>
+                        <a:t>巡检 / 重启 / 重部署</a:t>
                       </a:r>
                     </a:p>
                   </a:txBody>
@@ -4875,7 +4875,7 @@
         </p:nvGraphicFramePr>
         <p:xfrm>
           <a:off x="164592" y="3968496"/>
-          <a:ext cx="5848955" cy="2340864"/>
+          <a:ext cx="5848956" cy="2340864"/>
         </p:xfrm>
         <a:graphic>
           <a:graphicData uri="http://schemas.openxmlformats.org/drawingml/2006/table">
@@ -4884,12 +4884,11 @@
                 <a:tableStyleId>{5C22544A-7EE6-4342-B048-85BDC9FD1C3A}</a:tableStyleId>
               </a:tblPr>
               <a:tblGrid>
-                <a:gridCol w="822960"/>
-                <a:gridCol w="1005199"/>
-                <a:gridCol w="1005199"/>
-                <a:gridCol w="1005199"/>
-                <a:gridCol w="1005199"/>
-                <a:gridCol w="1005199"/>
+                <a:gridCol w="914400"/>
+                <a:gridCol w="1233639"/>
+                <a:gridCol w="1233639"/>
+                <a:gridCol w="1233639"/>
+                <a:gridCol w="1233639"/>
               </a:tblGrid>
               <a:tr h="292608">
                 <a:tc>
@@ -4951,29 +4950,6 @@
                           </a:solidFill>
                           <a:latin typeface="Calibri"/>
                         </a:rPr>
-                        <a:t>Stop</a:t>
-                      </a:r>
-                    </a:p>
-                  </a:txBody>
-                  <a:tcPr>
-                    <a:solidFill>
-                      <a:srgbClr val="275EA6"/>
-                    </a:solidFill>
-                  </a:tcPr>
-                </a:tc>
-                <a:tc>
-                  <a:txBody>
-                    <a:bodyPr wrap="none" lIns="38100" rIns="38100" tIns="25400" bIns="25400"/>
-                    <a:lstStyle/>
-                    <a:p>
-                      <a:pPr algn="ctr"/>
-                      <a:r>
-                        <a:rPr sz="850" b="1">
-                          <a:solidFill>
-                            <a:srgbClr val="FFFFFF"/>
-                          </a:solidFill>
-                          <a:latin typeface="Calibri"/>
-                        </a:rPr>
                         <a:t>Restart</a:t>
                       </a:r>
                     </a:p>
@@ -5133,29 +5109,6 @@
                       <a:r>
                         <a:rPr sz="850" b="0">
                           <a:solidFill>
-                            <a:srgbClr val="1A8A4A"/>
-                          </a:solidFill>
-                          <a:latin typeface="Calibri"/>
-                        </a:rPr>
-                        <a:t>✓</a:t>
-                      </a:r>
-                    </a:p>
-                  </a:txBody>
-                  <a:tcPr>
-                    <a:solidFill>
-                      <a:srgbClr val="F5F8FC"/>
-                    </a:solidFill>
-                  </a:tcPr>
-                </a:tc>
-                <a:tc>
-                  <a:txBody>
-                    <a:bodyPr wrap="none" lIns="38100" rIns="38100" tIns="25400" bIns="25400"/>
-                    <a:lstStyle/>
-                    <a:p>
-                      <a:pPr algn="ctr"/>
-                      <a:r>
-                        <a:rPr sz="850" b="0">
-                          <a:solidFill>
                             <a:srgbClr val="55657A"/>
                           </a:solidFill>
                           <a:latin typeface="Calibri"/>
@@ -5287,29 +5240,6 @@
                     </a:solidFill>
                   </a:tcPr>
                 </a:tc>
-                <a:tc>
-                  <a:txBody>
-                    <a:bodyPr wrap="none" lIns="38100" rIns="38100" tIns="25400" bIns="25400"/>
-                    <a:lstStyle/>
-                    <a:p>
-                      <a:pPr algn="ctr"/>
-                      <a:r>
-                        <a:rPr sz="850" b="0">
-                          <a:solidFill>
-                            <a:srgbClr val="1A8A4A"/>
-                          </a:solidFill>
-                          <a:latin typeface="Calibri"/>
-                        </a:rPr>
-                        <a:t>✓</a:t>
-                      </a:r>
-                    </a:p>
-                  </a:txBody>
-                  <a:tcPr>
-                    <a:solidFill>
-                      <a:srgbClr val="EBF3FB"/>
-                    </a:solidFill>
-                  </a:tcPr>
-                </a:tc>
               </a:tr>
               <a:tr h="292608">
                 <a:tc>
@@ -5413,29 +5343,6 @@
                       <a:r>
                         <a:rPr sz="850" b="0">
                           <a:solidFill>
-                            <a:srgbClr val="55657A"/>
-                          </a:solidFill>
-                          <a:latin typeface="Calibri"/>
-                        </a:rPr>
-                        <a:t>—</a:t>
-                      </a:r>
-                    </a:p>
-                  </a:txBody>
-                  <a:tcPr>
-                    <a:solidFill>
-                      <a:srgbClr val="F5F8FC"/>
-                    </a:solidFill>
-                  </a:tcPr>
-                </a:tc>
-                <a:tc>
-                  <a:txBody>
-                    <a:bodyPr wrap="none" lIns="38100" rIns="38100" tIns="25400" bIns="25400"/>
-                    <a:lstStyle/>
-                    <a:p>
-                      <a:pPr algn="ctr"/>
-                      <a:r>
-                        <a:rPr sz="850" b="0">
-                          <a:solidFill>
                             <a:srgbClr val="1A8A4A"/>
                           </a:solidFill>
                           <a:latin typeface="Calibri"/>
@@ -5567,29 +5474,6 @@
                     </a:solidFill>
                   </a:tcPr>
                 </a:tc>
-                <a:tc>
-                  <a:txBody>
-                    <a:bodyPr wrap="none" lIns="38100" rIns="38100" tIns="25400" bIns="25400"/>
-                    <a:lstStyle/>
-                    <a:p>
-                      <a:pPr algn="ctr"/>
-                      <a:r>
-                        <a:rPr sz="850" b="0">
-                          <a:solidFill>
-                            <a:srgbClr val="1A8A4A"/>
-                          </a:solidFill>
-                          <a:latin typeface="Calibri"/>
-                        </a:rPr>
-                        <a:t>✓</a:t>
-                      </a:r>
-                    </a:p>
-                  </a:txBody>
-                  <a:tcPr>
-                    <a:solidFill>
-                      <a:srgbClr val="EBF3FB"/>
-                    </a:solidFill>
-                  </a:tcPr>
-                </a:tc>
               </a:tr>
               <a:tr h="292608">
                 <a:tc>
@@ -5707,29 +5591,6 @@
                     </a:solidFill>
                   </a:tcPr>
                 </a:tc>
-                <a:tc>
-                  <a:txBody>
-                    <a:bodyPr wrap="none" lIns="38100" rIns="38100" tIns="25400" bIns="25400"/>
-                    <a:lstStyle/>
-                    <a:p>
-                      <a:pPr algn="ctr"/>
-                      <a:r>
-                        <a:rPr sz="850" b="0">
-                          <a:solidFill>
-                            <a:srgbClr val="1A8A4A"/>
-                          </a:solidFill>
-                          <a:latin typeface="Calibri"/>
-                        </a:rPr>
-                        <a:t>✓</a:t>
-                      </a:r>
-                    </a:p>
-                  </a:txBody>
-                  <a:tcPr>
-                    <a:solidFill>
-                      <a:srgbClr val="F5F8FC"/>
-                    </a:solidFill>
-                  </a:tcPr>
-                </a:tc>
               </a:tr>
               <a:tr h="292608">
                 <a:tc>
@@ -5833,29 +5694,6 @@
                       <a:r>
                         <a:rPr sz="850" b="0">
                           <a:solidFill>
-                            <a:srgbClr val="55657A"/>
-                          </a:solidFill>
-                          <a:latin typeface="Calibri"/>
-                        </a:rPr>
-                        <a:t>—</a:t>
-                      </a:r>
-                    </a:p>
-                  </a:txBody>
-                  <a:tcPr>
-                    <a:solidFill>
-                      <a:srgbClr val="EBF3FB"/>
-                    </a:solidFill>
-                  </a:tcPr>
-                </a:tc>
-                <a:tc>
-                  <a:txBody>
-                    <a:bodyPr wrap="none" lIns="38100" rIns="38100" tIns="25400" bIns="25400"/>
-                    <a:lstStyle/>
-                    <a:p>
-                      <a:pPr algn="ctr"/>
-                      <a:r>
-                        <a:rPr sz="850" b="0">
-                          <a:solidFill>
                             <a:srgbClr val="1A8A4A"/>
                           </a:solidFill>
                           <a:latin typeface="Calibri"/>
@@ -5892,29 +5730,6 @@
                   <a:tcPr>
                     <a:solidFill>
                       <a:srgbClr val="1A3A6B"/>
-                    </a:solidFill>
-                  </a:tcPr>
-                </a:tc>
-                <a:tc>
-                  <a:txBody>
-                    <a:bodyPr wrap="none" lIns="38100" rIns="38100" tIns="25400" bIns="25400"/>
-                    <a:lstStyle/>
-                    <a:p>
-                      <a:pPr algn="ctr"/>
-                      <a:r>
-                        <a:rPr sz="850" b="0">
-                          <a:solidFill>
-                            <a:srgbClr val="1A8A4A"/>
-                          </a:solidFill>
-                          <a:latin typeface="Calibri"/>
-                        </a:rPr>
-                        <a:t>✓</a:t>
-                      </a:r>
-                    </a:p>
-                  </a:txBody>
-                  <a:tcPr>
-                    <a:solidFill>
-                      <a:srgbClr val="F5F8FC"/>
                     </a:solidFill>
                   </a:tcPr>
                 </a:tc>
@@ -6528,7 +6343,7 @@
                 </a:solidFill>
                 <a:latin typeface="Calibri"/>
               </a:rPr>
-              <a:t>30 Playbooks  ·  38 Shared Tasks  ·  9 PowerShell Helpers  ·  7 设备类型  ·  develop 分支稳定  ·  2026-08</a:t>
+              <a:t>30 Playbooks  ·  38 Shared Tasks  ·  9 PowerShell Helpers  ·  当前 UI：巡检 / 重发 / 重启 / 重部署  ·  2026-08</a:t>
             </a:r>
           </a:p>
         </p:txBody>

</xml_diff>

<commit_message>
docs: merge device capability matrix and add fork features on PPT
Combine device-type coverage with the capability matrix into one native
table, drop recent-fix bullets, and list secondary-development capabilities
relative to upstream Semaphore.

Co-authored-by: plusand <alwaysneedlearn@users.noreply.github.com>
</commit_message>
<xml_diff>
--- a/docs/slides/semaphore_project_status.pptx
+++ b/docs/slides/semaphore_project_status.pptx
@@ -3140,7 +3140,7 @@
         <p:spPr>
           <a:xfrm>
             <a:off x="274320" y="54864"/>
-            <a:ext cx="10058400" cy="384048"/>
+            <a:ext cx="11430000" cy="384048"/>
           </a:xfrm>
           <a:prstGeom prst="rect">
             <a:avLst/>
@@ -3175,7 +3175,7 @@
         <p:spPr>
           <a:xfrm>
             <a:off x="320040" y="457200"/>
-            <a:ext cx="10058400" cy="256032"/>
+            <a:ext cx="11430000" cy="256032"/>
           </a:xfrm>
           <a:prstGeom prst="rect">
             <a:avLst/>
@@ -3196,7 +3196,7 @@
                 </a:solidFill>
                 <a:latin typeface="Calibri"/>
               </a:rPr>
-              <a:t>Go Backend + Vue.js 2 Frontend  ·  Ansible Playbooks (WinRM)  ·  当前设备列表 UI：巡检 / 重发 / 重启 / 重部署</a:t>
+              <a:t>相对原始 Semaphore 的二次开发  ·  Go + Vue.js 2  ·  Ansible WinRM  ·  设备列表：巡检 / 重发 / 重启 / 重部署</a:t>
             </a:r>
           </a:p>
         </p:txBody>
@@ -3274,7 +3274,7 @@
                 </a:solidFill>
                 <a:latin typeface="Calibri"/>
               </a:rPr>
-              <a:t>🏗  平台架构</a:t>
+              <a:t>平台架构</a:t>
             </a:r>
           </a:p>
         </p:txBody>
@@ -3288,7 +3288,7 @@
         <p:spPr>
           <a:xfrm>
             <a:off x="164592" y="1106424"/>
-            <a:ext cx="5848959" cy="2624328"/>
+            <a:ext cx="5848959" cy="2487168"/>
           </a:xfrm>
           <a:prstGeom prst="rect">
             <a:avLst/>
@@ -3333,7 +3333,7 @@
         <p:spPr>
           <a:xfrm>
             <a:off x="256032" y="1143000"/>
-            <a:ext cx="658368" cy="329184"/>
+            <a:ext cx="713232" cy="329184"/>
           </a:xfrm>
           <a:prstGeom prst="rect">
             <a:avLst/>
@@ -3367,8 +3367,8 @@
         </p:nvSpPr>
         <p:spPr>
           <a:xfrm>
-            <a:off x="932688" y="1143000"/>
-            <a:ext cx="4971135" cy="329184"/>
+            <a:off x="987552" y="1143000"/>
+            <a:ext cx="4897983" cy="329184"/>
           </a:xfrm>
           <a:prstGeom prst="rect">
             <a:avLst/>
@@ -3402,8 +3402,8 @@
         </p:nvSpPr>
         <p:spPr>
           <a:xfrm>
-            <a:off x="256032" y="1545336"/>
-            <a:ext cx="658368" cy="329184"/>
+            <a:off x="256032" y="1536192"/>
+            <a:ext cx="713232" cy="329184"/>
           </a:xfrm>
           <a:prstGeom prst="rect">
             <a:avLst/>
@@ -3437,8 +3437,8 @@
         </p:nvSpPr>
         <p:spPr>
           <a:xfrm>
-            <a:off x="932688" y="1545336"/>
-            <a:ext cx="4971135" cy="329184"/>
+            <a:off x="987552" y="1536192"/>
+            <a:ext cx="4897983" cy="329184"/>
           </a:xfrm>
           <a:prstGeom prst="rect">
             <a:avLst/>
@@ -3472,8 +3472,8 @@
         </p:nvSpPr>
         <p:spPr>
           <a:xfrm>
-            <a:off x="256032" y="1947672"/>
-            <a:ext cx="658368" cy="329184"/>
+            <a:off x="256032" y="1929384"/>
+            <a:ext cx="713232" cy="329184"/>
           </a:xfrm>
           <a:prstGeom prst="rect">
             <a:avLst/>
@@ -3507,8 +3507,8 @@
         </p:nvSpPr>
         <p:spPr>
           <a:xfrm>
-            <a:off x="932688" y="1947672"/>
-            <a:ext cx="4971135" cy="329184"/>
+            <a:off x="987552" y="1929384"/>
+            <a:ext cx="4897983" cy="329184"/>
           </a:xfrm>
           <a:prstGeom prst="rect">
             <a:avLst/>
@@ -3542,8 +3542,8 @@
         </p:nvSpPr>
         <p:spPr>
           <a:xfrm>
-            <a:off x="256032" y="2350008"/>
-            <a:ext cx="658368" cy="329184"/>
+            <a:off x="256032" y="2322576"/>
+            <a:ext cx="713232" cy="329184"/>
           </a:xfrm>
           <a:prstGeom prst="rect">
             <a:avLst/>
@@ -3577,8 +3577,8 @@
         </p:nvSpPr>
         <p:spPr>
           <a:xfrm>
-            <a:off x="932688" y="2350008"/>
-            <a:ext cx="4971135" cy="329184"/>
+            <a:off x="987552" y="2322576"/>
+            <a:ext cx="4897983" cy="329184"/>
           </a:xfrm>
           <a:prstGeom prst="rect">
             <a:avLst/>
@@ -3612,8 +3612,8 @@
         </p:nvSpPr>
         <p:spPr>
           <a:xfrm>
-            <a:off x="256032" y="2752344"/>
-            <a:ext cx="658368" cy="329184"/>
+            <a:off x="256032" y="2715768"/>
+            <a:ext cx="713232" cy="329184"/>
           </a:xfrm>
           <a:prstGeom prst="rect">
             <a:avLst/>
@@ -3647,8 +3647,8 @@
         </p:nvSpPr>
         <p:spPr>
           <a:xfrm>
-            <a:off x="932688" y="2752344"/>
-            <a:ext cx="4971135" cy="329184"/>
+            <a:off x="987552" y="2715768"/>
+            <a:ext cx="4897983" cy="329184"/>
           </a:xfrm>
           <a:prstGeom prst="rect">
             <a:avLst/>
@@ -3669,7 +3669,7 @@
                 </a:solidFill>
                 <a:latin typeface="Calibri"/>
               </a:rPr>
-              <a:t>Semaphore Schedules 定时巡检 · Patrol All · Probe TCP 探测</a:t>
+              <a:t>Semaphore Schedules 定时巡检重启 · Patrol All · Probe TCP</a:t>
             </a:r>
           </a:p>
         </p:txBody>
@@ -3682,8 +3682,8 @@
         </p:nvSpPr>
         <p:spPr>
           <a:xfrm>
-            <a:off x="256032" y="3154680"/>
-            <a:ext cx="658368" cy="329184"/>
+            <a:off x="256032" y="3108960"/>
+            <a:ext cx="713232" cy="329184"/>
           </a:xfrm>
           <a:prstGeom prst="rect">
             <a:avLst/>
@@ -3717,8 +3717,8 @@
         </p:nvSpPr>
         <p:spPr>
           <a:xfrm>
-            <a:off x="932688" y="3154680"/>
-            <a:ext cx="4971135" cy="329184"/>
+            <a:off x="987552" y="3108960"/>
+            <a:ext cx="4897983" cy="329184"/>
           </a:xfrm>
           <a:prstGeom prst="rect">
             <a:avLst/>
@@ -3817,7 +3817,7 @@
                 </a:solidFill>
                 <a:latin typeface="Calibri"/>
               </a:rPr>
-              <a:t>📋  设备类型覆盖（7 类）</a:t>
+              <a:t>二次开发重点增加的能力</a:t>
             </a:r>
           </a:p>
         </p:txBody>
@@ -3832,7 +3832,7 @@
         </p:nvGraphicFramePr>
         <p:xfrm>
           <a:off x="6178143" y="1106424"/>
-          <a:ext cx="4828032" cy="2624328"/>
+          <a:ext cx="5848959" cy="2487163"/>
         </p:xfrm>
         <a:graphic>
           <a:graphicData uri="http://schemas.openxmlformats.org/drawingml/2006/table">
@@ -3841,27 +3841,24 @@
                 <a:tableStyleId>{5C22544A-7EE6-4342-B048-85BDC9FD1C3A}</a:tableStyleId>
               </a:tblPr>
               <a:tblGrid>
-                <a:gridCol w="777240"/>
-                <a:gridCol w="932688"/>
-                <a:gridCol w="1170432"/>
-                <a:gridCol w="1051560"/>
-                <a:gridCol w="896112"/>
+                <a:gridCol w="1572768"/>
+                <a:gridCol w="4276191"/>
               </a:tblGrid>
-              <a:tr h="328041">
-                <a:tc>
-                  <a:txBody>
-                    <a:bodyPr wrap="none" lIns="38100" rIns="38100" tIns="25400" bIns="25400"/>
+              <a:tr h="355309">
+                <a:tc>
+                  <a:txBody>
+                    <a:bodyPr wrap="square" lIns="50800" rIns="50800" tIns="25400" bIns="25400"/>
                     <a:lstStyle/>
                     <a:p>
                       <a:pPr algn="l"/>
                       <a:r>
-                        <a:rPr sz="750" b="1">
+                        <a:rPr sz="800" b="1">
                           <a:solidFill>
                             <a:srgbClr val="FFFFFF"/>
                           </a:solidFill>
                           <a:latin typeface="Calibri"/>
                         </a:rPr>
-                        <a:t>设备类型</a:t>
+                        <a:t>能力</a:t>
                       </a:r>
                     </a:p>
                   </a:txBody>
@@ -3873,18 +3870,18 @@
                 </a:tc>
                 <a:tc>
                   <a:txBody>
-                    <a:bodyPr wrap="none" lIns="38100" rIns="38100" tIns="25400" bIns="25400"/>
-                    <a:lstStyle/>
-                    <a:p>
-                      <a:pPr algn="ctr"/>
-                      <a:r>
-                        <a:rPr sz="750" b="1">
+                    <a:bodyPr wrap="square" lIns="50800" rIns="50800" tIns="25400" bIns="25400"/>
+                    <a:lstStyle/>
+                    <a:p>
+                      <a:pPr algn="l"/>
+                      <a:r>
+                        <a:rPr sz="800" b="1">
                           <a:solidFill>
                             <a:srgbClr val="FFFFFF"/>
                           </a:solidFill>
                           <a:latin typeface="Calibri"/>
                         </a:rPr>
-                        <a:t>管控对象</a:t>
+                        <a:t>相对原始 Semaphore 新增</a:t>
                       </a:r>
                     </a:p>
                   </a:txBody>
@@ -3894,91 +3891,45 @@
                     </a:solidFill>
                   </a:tcPr>
                 </a:tc>
-                <a:tc>
-                  <a:txBody>
-                    <a:bodyPr wrap="none" lIns="38100" rIns="38100" tIns="25400" bIns="25400"/>
-                    <a:lstStyle/>
-                    <a:p>
-                      <a:pPr algn="ctr"/>
-                      <a:r>
-                        <a:rPr sz="750" b="1">
-                          <a:solidFill>
-                            <a:srgbClr val="FFFFFF"/>
-                          </a:solidFill>
-                          <a:latin typeface="Calibri"/>
-                        </a:rPr>
-                        <a:t>状态检测</a:t>
-                      </a:r>
-                    </a:p>
-                  </a:txBody>
-                  <a:tcPr>
-                    <a:solidFill>
-                      <a:srgbClr val="275EA6"/>
-                    </a:solidFill>
-                  </a:tcPr>
-                </a:tc>
-                <a:tc>
-                  <a:txBody>
-                    <a:bodyPr wrap="none" lIns="38100" rIns="38100" tIns="25400" bIns="25400"/>
-                    <a:lstStyle/>
-                    <a:p>
-                      <a:pPr algn="ctr"/>
-                      <a:r>
-                        <a:rPr sz="750" b="1">
-                          <a:solidFill>
-                            <a:srgbClr val="FFFFFF"/>
-                          </a:solidFill>
-                          <a:latin typeface="Calibri"/>
-                        </a:rPr>
-                        <a:t>当前 UI 操作</a:t>
-                      </a:r>
-                    </a:p>
-                  </a:txBody>
-                  <a:tcPr>
-                    <a:solidFill>
-                      <a:srgbClr val="275EA6"/>
-                    </a:solidFill>
-                  </a:tcPr>
-                </a:tc>
-                <a:tc>
-                  <a:txBody>
-                    <a:bodyPr wrap="none" lIns="38100" rIns="38100" tIns="25400" bIns="25400"/>
-                    <a:lstStyle/>
-                    <a:p>
-                      <a:pPr algn="ctr"/>
-                      <a:r>
-                        <a:rPr sz="750" b="1">
-                          <a:solidFill>
-                            <a:srgbClr val="FFFFFF"/>
-                          </a:solidFill>
-                          <a:latin typeface="Calibri"/>
-                        </a:rPr>
-                        <a:t>数据重传</a:t>
-                      </a:r>
-                    </a:p>
-                  </a:txBody>
-                  <a:tcPr>
-                    <a:solidFill>
-                      <a:srgbClr val="275EA6"/>
-                    </a:solidFill>
-                  </a:tcPr>
-                </a:tc>
               </a:tr>
-              <a:tr h="328041">
-                <a:tc>
-                  <a:txBody>
-                    <a:bodyPr wrap="none" lIns="38100" rIns="38100" tIns="25400" bIns="25400"/>
+              <a:tr h="355309">
+                <a:tc>
+                  <a:txBody>
+                    <a:bodyPr wrap="square" lIns="50800" rIns="50800" tIns="25400" bIns="25400"/>
                     <a:lstStyle/>
                     <a:p>
                       <a:pPr algn="l"/>
                       <a:r>
-                        <a:rPr sz="750" b="0">
+                        <a:rPr sz="800" b="1">
+                          <a:solidFill>
+                            <a:srgbClr val="1A3A6B"/>
+                          </a:solidFill>
+                          <a:latin typeface="Calibri"/>
+                        </a:rPr>
+                        <a:t>设备管理体系</a:t>
+                      </a:r>
+                    </a:p>
+                  </a:txBody>
+                  <a:tcPr>
+                    <a:solidFill>
+                      <a:srgbClr val="F5F8FC"/>
+                    </a:solidFill>
+                  </a:tcPr>
+                </a:tc>
+                <a:tc>
+                  <a:txBody>
+                    <a:bodyPr wrap="square" lIns="50800" rIns="50800" tIns="25400" bIns="25400"/>
+                    <a:lstStyle/>
+                    <a:p>
+                      <a:pPr algn="l"/>
+                      <a:r>
+                        <a:rPr sz="800" b="0">
                           <a:solidFill>
                             <a:srgbClr val="1A1A2E"/>
                           </a:solidFill>
                           <a:latin typeface="Calibri"/>
                         </a:rPr>
-                        <a:t>NEWARE</a:t>
+                        <a:t>设备列表、设备类型、Discovery 扫描导入、Probe、批量操作</a:t>
                       </a:r>
                     </a:p>
                   </a:txBody>
@@ -3988,20 +3939,70 @@
                     </a:solidFill>
                   </a:tcPr>
                 </a:tc>
-                <a:tc>
-                  <a:txBody>
-                    <a:bodyPr wrap="none" lIns="38100" rIns="38100" tIns="25400" bIns="25400"/>
-                    <a:lstStyle/>
-                    <a:p>
-                      <a:pPr algn="ctr"/>
-                      <a:r>
-                        <a:rPr sz="750" b="0">
+              </a:tr>
+              <a:tr h="355309">
+                <a:tc>
+                  <a:txBody>
+                    <a:bodyPr wrap="square" lIns="50800" rIns="50800" tIns="25400" bIns="25400"/>
+                    <a:lstStyle/>
+                    <a:p>
+                      <a:pPr algn="l"/>
+                      <a:r>
+                        <a:rPr sz="800" b="1">
+                          <a:solidFill>
+                            <a:srgbClr val="1A3A6B"/>
+                          </a:solidFill>
+                          <a:latin typeface="Calibri"/>
+                        </a:rPr>
+                        <a:t>Playbook 运维闭环</a:t>
+                      </a:r>
+                    </a:p>
+                  </a:txBody>
+                  <a:tcPr>
+                    <a:solidFill>
+                      <a:srgbClr val="EBF3FB"/>
+                    </a:solidFill>
+                  </a:tcPr>
+                </a:tc>
+                <a:tc>
+                  <a:txBody>
+                    <a:bodyPr wrap="square" lIns="50800" rIns="50800" tIns="25400" bIns="25400"/>
+                    <a:lstStyle/>
+                    <a:p>
+                      <a:pPr algn="l"/>
+                      <a:r>
+                        <a:rPr sz="800" b="0">
                           <a:solidFill>
                             <a:srgbClr val="1A1A2E"/>
                           </a:solidFill>
                           <a:latin typeface="Calibri"/>
                         </a:rPr>
-                        <a:t>uu.exe</a:t>
+                        <a:t>按类型绑定巡检 / 重发 / 重启 / 重部署模板并远程执行</a:t>
+                      </a:r>
+                    </a:p>
+                  </a:txBody>
+                  <a:tcPr>
+                    <a:solidFill>
+                      <a:srgbClr val="EBF3FB"/>
+                    </a:solidFill>
+                  </a:tcPr>
+                </a:tc>
+              </a:tr>
+              <a:tr h="355309">
+                <a:tc>
+                  <a:txBody>
+                    <a:bodyPr wrap="square" lIns="50800" rIns="50800" tIns="25400" bIns="25400"/>
+                    <a:lstStyle/>
+                    <a:p>
+                      <a:pPr algn="l"/>
+                      <a:r>
+                        <a:rPr sz="800" b="1">
+                          <a:solidFill>
+                            <a:srgbClr val="1A3A6B"/>
+                          </a:solidFill>
+                          <a:latin typeface="Calibri"/>
+                        </a:rPr>
+                        <a:t>设备状态回写</a:t>
                       </a:r>
                     </a:p>
                   </a:txBody>
@@ -4013,18 +4014,18 @@
                 </a:tc>
                 <a:tc>
                   <a:txBody>
-                    <a:bodyPr wrap="none" lIns="38100" rIns="38100" tIns="25400" bIns="25400"/>
-                    <a:lstStyle/>
-                    <a:p>
-                      <a:pPr algn="ctr"/>
-                      <a:r>
-                        <a:rPr sz="750" b="0">
+                    <a:bodyPr wrap="square" lIns="50800" rIns="50800" tIns="25400" bIns="25400"/>
+                    <a:lstStyle/>
+                    <a:p>
+                      <a:pPr algn="l"/>
+                      <a:r>
+                        <a:rPr sz="800" b="0">
                           <a:solidFill>
                             <a:srgbClr val="1A1A2E"/>
                           </a:solidFill>
                           <a:latin typeface="Calibri"/>
                         </a:rPr>
-                        <a:t>进程 + API</a:t>
+                        <a:t>playbook bulk callback 回写 device_status / WinRM / API</a:t>
                       </a:r>
                     </a:p>
                   </a:txBody>
@@ -4034,20 +4035,70 @@
                     </a:solidFill>
                   </a:tcPr>
                 </a:tc>
-                <a:tc>
-                  <a:txBody>
-                    <a:bodyPr wrap="none" lIns="38100" rIns="38100" tIns="25400" bIns="25400"/>
-                    <a:lstStyle/>
-                    <a:p>
-                      <a:pPr algn="ctr"/>
-                      <a:r>
-                        <a:rPr sz="750" b="0">
+              </a:tr>
+              <a:tr h="355309">
+                <a:tc>
+                  <a:txBody>
+                    <a:bodyPr wrap="square" lIns="50800" rIns="50800" tIns="25400" bIns="25400"/>
+                    <a:lstStyle/>
+                    <a:p>
+                      <a:pPr algn="l"/>
+                      <a:r>
+                        <a:rPr sz="800" b="1">
+                          <a:solidFill>
+                            <a:srgbClr val="1A3A6B"/>
+                          </a:solidFill>
+                          <a:latin typeface="Calibri"/>
+                        </a:rPr>
+                        <a:t>TDengine 通道监控</a:t>
+                      </a:r>
+                    </a:p>
+                  </a:txBody>
+                  <a:tcPr>
+                    <a:solidFill>
+                      <a:srgbClr val="EBF3FB"/>
+                    </a:solidFill>
+                  </a:tcPr>
+                </a:tc>
+                <a:tc>
+                  <a:txBody>
+                    <a:bodyPr wrap="square" lIns="50800" rIns="50800" tIns="25400" bIns="25400"/>
+                    <a:lstStyle/>
+                    <a:p>
+                      <a:pPr algn="l"/>
+                      <a:r>
+                        <a:rPr sz="800" b="0">
                           <a:solidFill>
                             <a:srgbClr val="1A1A2E"/>
                           </a:solidFill>
                           <a:latin typeface="Calibri"/>
                         </a:rPr>
-                        <a:t>巡检 / 重启 / 重部署</a:t>
+                        <a:t>时序状态快照；check_restart 先看通道新鲜度再决定重启</a:t>
+                      </a:r>
+                    </a:p>
+                  </a:txBody>
+                  <a:tcPr>
+                    <a:solidFill>
+                      <a:srgbClr val="EBF3FB"/>
+                    </a:solidFill>
+                  </a:tcPr>
+                </a:tc>
+              </a:tr>
+              <a:tr h="355309">
+                <a:tc>
+                  <a:txBody>
+                    <a:bodyPr wrap="square" lIns="50800" rIns="50800" tIns="25400" bIns="25400"/>
+                    <a:lstStyle/>
+                    <a:p>
+                      <a:pPr algn="l"/>
+                      <a:r>
+                        <a:rPr sz="800" b="1">
+                          <a:solidFill>
+                            <a:srgbClr val="1A3A6B"/>
+                          </a:solidFill>
+                          <a:latin typeface="Calibri"/>
+                        </a:rPr>
+                        <a:t>RDP Helper</a:t>
                       </a:r>
                     </a:p>
                   </a:txBody>
@@ -4059,18 +4110,18 @@
                 </a:tc>
                 <a:tc>
                   <a:txBody>
-                    <a:bodyPr wrap="none" lIns="38100" rIns="38100" tIns="25400" bIns="25400"/>
-                    <a:lstStyle/>
-                    <a:p>
-                      <a:pPr algn="ctr"/>
-                      <a:r>
-                        <a:rPr sz="750" b="0">
+                    <a:bodyPr wrap="square" lIns="50800" rIns="50800" tIns="25400" bIns="25400"/>
+                    <a:lstStyle/>
+                    <a:p>
+                      <a:pPr algn="l"/>
+                      <a:r>
+                        <a:rPr sz="800" b="0">
                           <a:solidFill>
                             <a:srgbClr val="1A1A2E"/>
                           </a:solidFill>
                           <a:latin typeface="Calibri"/>
                         </a:rPr>
-                        <a:t>—（INI）</a:t>
+                        <a:t>Web 唤起本机 mstsc 远程桌面，含启动/结束审计</a:t>
                       </a:r>
                     </a:p>
                   </a:txBody>
@@ -4081,704 +4132,50 @@
                   </a:tcPr>
                 </a:tc>
               </a:tr>
-              <a:tr h="328041">
-                <a:tc>
-                  <a:txBody>
-                    <a:bodyPr wrap="none" lIns="38100" rIns="38100" tIns="25400" bIns="25400"/>
+              <a:tr h="355309">
+                <a:tc>
+                  <a:txBody>
+                    <a:bodyPr wrap="square" lIns="50800" rIns="50800" tIns="25400" bIns="25400"/>
                     <a:lstStyle/>
                     <a:p>
                       <a:pPr algn="l"/>
                       <a:r>
-                        <a:rPr sz="750" b="0">
+                        <a:rPr sz="800" b="1">
+                          <a:solidFill>
+                            <a:srgbClr val="1A3A6B"/>
+                          </a:solidFill>
+                          <a:latin typeface="Calibri"/>
+                        </a:rPr>
+                        <a:t>任务日志独立页</a:t>
+                      </a:r>
+                    </a:p>
+                  </a:txBody>
+                  <a:tcPr>
+                    <a:solidFill>
+                      <a:srgbClr val="EBF3FB"/>
+                    </a:solidFill>
+                  </a:tcPr>
+                </a:tc>
+                <a:tc>
+                  <a:txBody>
+                    <a:bodyPr wrap="square" lIns="50800" rIns="50800" tIns="25400" bIns="25400"/>
+                    <a:lstStyle/>
+                    <a:p>
+                      <a:pPr algn="l"/>
+                      <a:r>
+                        <a:rPr sz="800" b="0">
                           <a:solidFill>
                             <a:srgbClr val="1A1A2E"/>
                           </a:solidFill>
                           <a:latin typeface="Calibri"/>
                         </a:rPr>
-                        <a:t>LAND</a:t>
+                        <a:t>任务日志新标签页打开，不遮挡设备列表</a:t>
                       </a:r>
                     </a:p>
                   </a:txBody>
                   <a:tcPr>
                     <a:solidFill>
                       <a:srgbClr val="EBF3FB"/>
-                    </a:solidFill>
-                  </a:tcPr>
-                </a:tc>
-                <a:tc>
-                  <a:txBody>
-                    <a:bodyPr wrap="none" lIns="38100" rIns="38100" tIns="25400" bIns="25400"/>
-                    <a:lstStyle/>
-                    <a:p>
-                      <a:pPr algn="ctr"/>
-                      <a:r>
-                        <a:rPr sz="750" b="0">
-                          <a:solidFill>
-                            <a:srgbClr val="1A1A2E"/>
-                          </a:solidFill>
-                          <a:latin typeface="Calibri"/>
-                        </a:rPr>
-                        <a:t>LHBTS.exe</a:t>
-                      </a:r>
-                    </a:p>
-                  </a:txBody>
-                  <a:tcPr>
-                    <a:solidFill>
-                      <a:srgbClr val="EBF3FB"/>
-                    </a:solidFill>
-                  </a:tcPr>
-                </a:tc>
-                <a:tc>
-                  <a:txBody>
-                    <a:bodyPr wrap="none" lIns="38100" rIns="38100" tIns="25400" bIns="25400"/>
-                    <a:lstStyle/>
-                    <a:p>
-                      <a:pPr algn="ctr"/>
-                      <a:r>
-                        <a:rPr sz="750" b="0">
-                          <a:solidFill>
-                            <a:srgbClr val="1A3A6B"/>
-                          </a:solidFill>
-                          <a:latin typeface="Calibri"/>
-                        </a:rPr>
-                        <a:t>QueryStatus</a:t>
-                      </a:r>
-                    </a:p>
-                  </a:txBody>
-                  <a:tcPr>
-                    <a:solidFill>
-                      <a:srgbClr val="EBF3FB"/>
-                    </a:solidFill>
-                  </a:tcPr>
-                </a:tc>
-                <a:tc>
-                  <a:txBody>
-                    <a:bodyPr wrap="none" lIns="38100" rIns="38100" tIns="25400" bIns="25400"/>
-                    <a:lstStyle/>
-                    <a:p>
-                      <a:pPr algn="ctr"/>
-                      <a:r>
-                        <a:rPr sz="750" b="0">
-                          <a:solidFill>
-                            <a:srgbClr val="1A1A2E"/>
-                          </a:solidFill>
-                          <a:latin typeface="Calibri"/>
-                        </a:rPr>
-                        <a:t>巡检 / 重启 / 重部署</a:t>
-                      </a:r>
-                    </a:p>
-                  </a:txBody>
-                  <a:tcPr>
-                    <a:solidFill>
-                      <a:srgbClr val="EBF3FB"/>
-                    </a:solidFill>
-                  </a:tcPr>
-                </a:tc>
-                <a:tc>
-                  <a:txBody>
-                    <a:bodyPr wrap="none" lIns="38100" rIns="38100" tIns="25400" bIns="25400"/>
-                    <a:lstStyle/>
-                    <a:p>
-                      <a:pPr algn="ctr"/>
-                      <a:r>
-                        <a:rPr sz="750" b="0">
-                          <a:solidFill>
-                            <a:srgbClr val="1A1A2E"/>
-                          </a:solidFill>
-                          <a:latin typeface="Calibri"/>
-                        </a:rPr>
-                        <a:t>Redeliver</a:t>
-                      </a:r>
-                    </a:p>
-                  </a:txBody>
-                  <a:tcPr>
-                    <a:solidFill>
-                      <a:srgbClr val="EBF3FB"/>
-                    </a:solidFill>
-                  </a:tcPr>
-                </a:tc>
-              </a:tr>
-              <a:tr h="328041">
-                <a:tc>
-                  <a:txBody>
-                    <a:bodyPr wrap="none" lIns="38100" rIns="38100" tIns="25400" bIns="25400"/>
-                    <a:lstStyle/>
-                    <a:p>
-                      <a:pPr algn="l"/>
-                      <a:r>
-                        <a:rPr sz="750" b="0">
-                          <a:solidFill>
-                            <a:srgbClr val="1A1A2E"/>
-                          </a:solidFill>
-                          <a:latin typeface="Calibri"/>
-                        </a:rPr>
-                        <a:t>LANH</a:t>
-                      </a:r>
-                    </a:p>
-                  </a:txBody>
-                  <a:tcPr>
-                    <a:solidFill>
-                      <a:srgbClr val="F5F8FC"/>
-                    </a:solidFill>
-                  </a:tcPr>
-                </a:tc>
-                <a:tc>
-                  <a:txBody>
-                    <a:bodyPr wrap="none" lIns="38100" rIns="38100" tIns="25400" bIns="25400"/>
-                    <a:lstStyle/>
-                    <a:p>
-                      <a:pPr algn="ctr"/>
-                      <a:r>
-                        <a:rPr sz="750" b="0">
-                          <a:solidFill>
-                            <a:srgbClr val="1A1A2E"/>
-                          </a:solidFill>
-                          <a:latin typeface="Calibri"/>
-                        </a:rPr>
-                        <a:t>ccsmon.exe</a:t>
-                      </a:r>
-                    </a:p>
-                  </a:txBody>
-                  <a:tcPr>
-                    <a:solidFill>
-                      <a:srgbClr val="F5F8FC"/>
-                    </a:solidFill>
-                  </a:tcPr>
-                </a:tc>
-                <a:tc>
-                  <a:txBody>
-                    <a:bodyPr wrap="none" lIns="38100" rIns="38100" tIns="25400" bIns="25400"/>
-                    <a:lstStyle/>
-                    <a:p>
-                      <a:pPr algn="ctr"/>
-                      <a:r>
-                        <a:rPr sz="750" b="0">
-                          <a:solidFill>
-                            <a:srgbClr val="1A3A6B"/>
-                          </a:solidFill>
-                          <a:latin typeface="Calibri"/>
-                        </a:rPr>
-                        <a:t>QueryStatus</a:t>
-                      </a:r>
-                    </a:p>
-                  </a:txBody>
-                  <a:tcPr>
-                    <a:solidFill>
-                      <a:srgbClr val="F5F8FC"/>
-                    </a:solidFill>
-                  </a:tcPr>
-                </a:tc>
-                <a:tc>
-                  <a:txBody>
-                    <a:bodyPr wrap="none" lIns="38100" rIns="38100" tIns="25400" bIns="25400"/>
-                    <a:lstStyle/>
-                    <a:p>
-                      <a:pPr algn="ctr"/>
-                      <a:r>
-                        <a:rPr sz="750" b="0">
-                          <a:solidFill>
-                            <a:srgbClr val="1A1A2E"/>
-                          </a:solidFill>
-                          <a:latin typeface="Calibri"/>
-                        </a:rPr>
-                        <a:t>巡检 / 重发</a:t>
-                      </a:r>
-                    </a:p>
-                  </a:txBody>
-                  <a:tcPr>
-                    <a:solidFill>
-                      <a:srgbClr val="F5F8FC"/>
-                    </a:solidFill>
-                  </a:tcPr>
-                </a:tc>
-                <a:tc>
-                  <a:txBody>
-                    <a:bodyPr wrap="none" lIns="38100" rIns="38100" tIns="25400" bIns="25400"/>
-                    <a:lstStyle/>
-                    <a:p>
-                      <a:pPr algn="ctr"/>
-                      <a:r>
-                        <a:rPr sz="750" b="0">
-                          <a:solidFill>
-                            <a:srgbClr val="1A1A2E"/>
-                          </a:solidFill>
-                          <a:latin typeface="Calibri"/>
-                        </a:rPr>
-                        <a:t>Redeliver</a:t>
-                      </a:r>
-                    </a:p>
-                  </a:txBody>
-                  <a:tcPr>
-                    <a:solidFill>
-                      <a:srgbClr val="F5F8FC"/>
-                    </a:solidFill>
-                  </a:tcPr>
-                </a:tc>
-              </a:tr>
-              <a:tr h="328041">
-                <a:tc>
-                  <a:txBody>
-                    <a:bodyPr wrap="none" lIns="38100" rIns="38100" tIns="25400" bIns="25400"/>
-                    <a:lstStyle/>
-                    <a:p>
-                      <a:pPr algn="l"/>
-                      <a:r>
-                        <a:rPr sz="750" b="0">
-                          <a:solidFill>
-                            <a:srgbClr val="1A1A2E"/>
-                          </a:solidFill>
-                          <a:latin typeface="Calibri"/>
-                        </a:rPr>
-                        <a:t>SINEXCEL</a:t>
-                      </a:r>
-                    </a:p>
-                  </a:txBody>
-                  <a:tcPr>
-                    <a:solidFill>
-                      <a:srgbClr val="EBF3FB"/>
-                    </a:solidFill>
-                  </a:tcPr>
-                </a:tc>
-                <a:tc>
-                  <a:txBody>
-                    <a:bodyPr wrap="none" lIns="38100" rIns="38100" tIns="25400" bIns="25400"/>
-                    <a:lstStyle/>
-                    <a:p>
-                      <a:pPr algn="ctr"/>
-                      <a:r>
-                        <a:rPr sz="750" b="0">
-                          <a:solidFill>
-                            <a:srgbClr val="1A1A2E"/>
-                          </a:solidFill>
-                          <a:latin typeface="Calibri"/>
-                        </a:rPr>
-                        <a:t>agent.exe</a:t>
-                      </a:r>
-                    </a:p>
-                  </a:txBody>
-                  <a:tcPr>
-                    <a:solidFill>
-                      <a:srgbClr val="EBF3FB"/>
-                    </a:solidFill>
-                  </a:tcPr>
-                </a:tc>
-                <a:tc>
-                  <a:txBody>
-                    <a:bodyPr wrap="none" lIns="38100" rIns="38100" tIns="25400" bIns="25400"/>
-                    <a:lstStyle/>
-                    <a:p>
-                      <a:pPr algn="ctr"/>
-                      <a:r>
-                        <a:rPr sz="750" b="0">
-                          <a:solidFill>
-                            <a:srgbClr val="1A3A6B"/>
-                          </a:solidFill>
-                          <a:latin typeface="Calibri"/>
-                        </a:rPr>
-                        <a:t>QueryConfig</a:t>
-                      </a:r>
-                    </a:p>
-                  </a:txBody>
-                  <a:tcPr>
-                    <a:solidFill>
-                      <a:srgbClr val="EBF3FB"/>
-                    </a:solidFill>
-                  </a:tcPr>
-                </a:tc>
-                <a:tc>
-                  <a:txBody>
-                    <a:bodyPr wrap="none" lIns="38100" rIns="38100" tIns="25400" bIns="25400"/>
-                    <a:lstStyle/>
-                    <a:p>
-                      <a:pPr algn="ctr"/>
-                      <a:r>
-                        <a:rPr sz="750" b="0">
-                          <a:solidFill>
-                            <a:srgbClr val="1A1A2E"/>
-                          </a:solidFill>
-                          <a:latin typeface="Calibri"/>
-                        </a:rPr>
-                        <a:t>巡检 / 重启 / 重部署</a:t>
-                      </a:r>
-                    </a:p>
-                  </a:txBody>
-                  <a:tcPr>
-                    <a:solidFill>
-                      <a:srgbClr val="EBF3FB"/>
-                    </a:solidFill>
-                  </a:tcPr>
-                </a:tc>
-                <a:tc>
-                  <a:txBody>
-                    <a:bodyPr wrap="none" lIns="38100" rIns="38100" tIns="25400" bIns="25400"/>
-                    <a:lstStyle/>
-                    <a:p>
-                      <a:pPr algn="ctr"/>
-                      <a:r>
-                        <a:rPr sz="750" b="0">
-                          <a:solidFill>
-                            <a:srgbClr val="1A1A2E"/>
-                          </a:solidFill>
-                          <a:latin typeface="Calibri"/>
-                        </a:rPr>
-                        <a:t>Retransmit</a:t>
-                      </a:r>
-                    </a:p>
-                  </a:txBody>
-                  <a:tcPr>
-                    <a:solidFill>
-                      <a:srgbClr val="EBF3FB"/>
-                    </a:solidFill>
-                  </a:tcPr>
-                </a:tc>
-              </a:tr>
-              <a:tr h="328041">
-                <a:tc>
-                  <a:txBody>
-                    <a:bodyPr wrap="none" lIns="38100" rIns="38100" tIns="25400" bIns="25400"/>
-                    <a:lstStyle/>
-                    <a:p>
-                      <a:pPr algn="l"/>
-                      <a:r>
-                        <a:rPr sz="750" b="0">
-                          <a:solidFill>
-                            <a:srgbClr val="1A1A2E"/>
-                          </a:solidFill>
-                          <a:latin typeface="Calibri"/>
-                        </a:rPr>
-                        <a:t>NBT</a:t>
-                      </a:r>
-                    </a:p>
-                  </a:txBody>
-                  <a:tcPr>
-                    <a:solidFill>
-                      <a:srgbClr val="F5F8FC"/>
-                    </a:solidFill>
-                  </a:tcPr>
-                </a:tc>
-                <a:tc>
-                  <a:txBody>
-                    <a:bodyPr wrap="none" lIns="38100" rIns="38100" tIns="25400" bIns="25400"/>
-                    <a:lstStyle/>
-                    <a:p>
-                      <a:pPr algn="ctr"/>
-                      <a:r>
-                        <a:rPr sz="750" b="0">
-                          <a:solidFill>
-                            <a:srgbClr val="1A1A2E"/>
-                          </a:solidFill>
-                          <a:latin typeface="Calibri"/>
-                        </a:rPr>
-                        <a:t>Win 服务</a:t>
-                      </a:r>
-                    </a:p>
-                  </a:txBody>
-                  <a:tcPr>
-                    <a:solidFill>
-                      <a:srgbClr val="F5F8FC"/>
-                    </a:solidFill>
-                  </a:tcPr>
-                </a:tc>
-                <a:tc>
-                  <a:txBody>
-                    <a:bodyPr wrap="none" lIns="38100" rIns="38100" tIns="25400" bIns="25400"/>
-                    <a:lstStyle/>
-                    <a:p>
-                      <a:pPr algn="ctr"/>
-                      <a:r>
-                        <a:rPr sz="750" b="0">
-                          <a:solidFill>
-                            <a:srgbClr val="1A1A2E"/>
-                          </a:solidFill>
-                          <a:latin typeface="Calibri"/>
-                        </a:rPr>
-                        <a:t>服务 + 心跳</a:t>
-                      </a:r>
-                    </a:p>
-                  </a:txBody>
-                  <a:tcPr>
-                    <a:solidFill>
-                      <a:srgbClr val="F5F8FC"/>
-                    </a:solidFill>
-                  </a:tcPr>
-                </a:tc>
-                <a:tc>
-                  <a:txBody>
-                    <a:bodyPr wrap="none" lIns="38100" rIns="38100" tIns="25400" bIns="25400"/>
-                    <a:lstStyle/>
-                    <a:p>
-                      <a:pPr algn="ctr"/>
-                      <a:r>
-                        <a:rPr sz="750" b="0">
-                          <a:solidFill>
-                            <a:srgbClr val="1A1A2E"/>
-                          </a:solidFill>
-                          <a:latin typeface="Calibri"/>
-                        </a:rPr>
-                        <a:t>巡检 / 重启 / 重部署</a:t>
-                      </a:r>
-                    </a:p>
-                  </a:txBody>
-                  <a:tcPr>
-                    <a:solidFill>
-                      <a:srgbClr val="F5F8FC"/>
-                    </a:solidFill>
-                  </a:tcPr>
-                </a:tc>
-                <a:tc>
-                  <a:txBody>
-                    <a:bodyPr wrap="none" lIns="38100" rIns="38100" tIns="25400" bIns="25400"/>
-                    <a:lstStyle/>
-                    <a:p>
-                      <a:pPr algn="ctr"/>
-                      <a:r>
-                        <a:rPr sz="750" b="0">
-                          <a:solidFill>
-                            <a:srgbClr val="1A1A2E"/>
-                          </a:solidFill>
-                          <a:latin typeface="Calibri"/>
-                        </a:rPr>
-                        <a:t>ResetData</a:t>
-                      </a:r>
-                    </a:p>
-                  </a:txBody>
-                  <a:tcPr>
-                    <a:solidFill>
-                      <a:srgbClr val="F5F8FC"/>
-                    </a:solidFill>
-                  </a:tcPr>
-                </a:tc>
-              </a:tr>
-              <a:tr h="328041">
-                <a:tc>
-                  <a:txBody>
-                    <a:bodyPr wrap="none" lIns="38100" rIns="38100" tIns="25400" bIns="25400"/>
-                    <a:lstStyle/>
-                    <a:p>
-                      <a:pPr algn="l"/>
-                      <a:r>
-                        <a:rPr sz="750" b="0">
-                          <a:solidFill>
-                            <a:srgbClr val="1A1A2E"/>
-                          </a:solidFill>
-                          <a:latin typeface="Calibri"/>
-                        </a:rPr>
-                        <a:t>DAHUA</a:t>
-                      </a:r>
-                    </a:p>
-                  </a:txBody>
-                  <a:tcPr>
-                    <a:solidFill>
-                      <a:srgbClr val="EBF3FB"/>
-                    </a:solidFill>
-                  </a:tcPr>
-                </a:tc>
-                <a:tc>
-                  <a:txBody>
-                    <a:bodyPr wrap="none" lIns="38100" rIns="38100" tIns="25400" bIns="25400"/>
-                    <a:lstStyle/>
-                    <a:p>
-                      <a:pPr algn="ctr"/>
-                      <a:r>
-                        <a:rPr sz="750" b="0">
-                          <a:solidFill>
-                            <a:srgbClr val="1A1A2E"/>
-                          </a:solidFill>
-                          <a:latin typeface="Calibri"/>
-                        </a:rPr>
-                        <a:t>lims-hist</a:t>
-                      </a:r>
-                    </a:p>
-                  </a:txBody>
-                  <a:tcPr>
-                    <a:solidFill>
-                      <a:srgbClr val="EBF3FB"/>
-                    </a:solidFill>
-                  </a:tcPr>
-                </a:tc>
-                <a:tc>
-                  <a:txBody>
-                    <a:bodyPr wrap="none" lIns="38100" rIns="38100" tIns="25400" bIns="25400"/>
-                    <a:lstStyle/>
-                    <a:p>
-                      <a:pPr algn="ctr"/>
-                      <a:r>
-                        <a:rPr sz="750" b="0">
-                          <a:solidFill>
-                            <a:srgbClr val="1A1A2E"/>
-                          </a:solidFill>
-                          <a:latin typeface="Calibri"/>
-                        </a:rPr>
-                        <a:t>—</a:t>
-                      </a:r>
-                    </a:p>
-                  </a:txBody>
-                  <a:tcPr>
-                    <a:solidFill>
-                      <a:srgbClr val="EBF3FB"/>
-                    </a:solidFill>
-                  </a:tcPr>
-                </a:tc>
-                <a:tc>
-                  <a:txBody>
-                    <a:bodyPr wrap="none" lIns="38100" rIns="38100" tIns="25400" bIns="25400"/>
-                    <a:lstStyle/>
-                    <a:p>
-                      <a:pPr algn="ctr"/>
-                      <a:r>
-                        <a:rPr sz="750" b="0">
-                          <a:solidFill>
-                            <a:srgbClr val="1A1A2E"/>
-                          </a:solidFill>
-                          <a:latin typeface="Calibri"/>
-                        </a:rPr>
-                        <a:t>仅重发</a:t>
-                      </a:r>
-                    </a:p>
-                  </a:txBody>
-                  <a:tcPr>
-                    <a:solidFill>
-                      <a:srgbClr val="EBF3FB"/>
-                    </a:solidFill>
-                  </a:tcPr>
-                </a:tc>
-                <a:tc>
-                  <a:txBody>
-                    <a:bodyPr wrap="none" lIns="38100" rIns="38100" tIns="25400" bIns="25400"/>
-                    <a:lstStyle/>
-                    <a:p>
-                      <a:pPr algn="ctr"/>
-                      <a:r>
-                        <a:rPr sz="750" b="0">
-                          <a:solidFill>
-                            <a:srgbClr val="1A1A2E"/>
-                          </a:solidFill>
-                          <a:latin typeface="Calibri"/>
-                        </a:rPr>
-                        <a:t>CLI 重发</a:t>
-                      </a:r>
-                    </a:p>
-                  </a:txBody>
-                  <a:tcPr>
-                    <a:solidFill>
-                      <a:srgbClr val="EBF3FB"/>
-                    </a:solidFill>
-                  </a:tcPr>
-                </a:tc>
-              </a:tr>
-              <a:tr h="328041">
-                <a:tc>
-                  <a:txBody>
-                    <a:bodyPr wrap="none" lIns="38100" rIns="38100" tIns="25400" bIns="25400"/>
-                    <a:lstStyle/>
-                    <a:p>
-                      <a:pPr algn="l"/>
-                      <a:r>
-                        <a:rPr sz="750" b="0">
-                          <a:solidFill>
-                            <a:srgbClr val="1A1A2E"/>
-                          </a:solidFill>
-                          <a:latin typeface="Calibri"/>
-                        </a:rPr>
-                        <a:t>JHAI</a:t>
-                      </a:r>
-                    </a:p>
-                  </a:txBody>
-                  <a:tcPr>
-                    <a:solidFill>
-                      <a:srgbClr val="F5F8FC"/>
-                    </a:solidFill>
-                  </a:tcPr>
-                </a:tc>
-                <a:tc>
-                  <a:txBody>
-                    <a:bodyPr wrap="none" lIns="38100" rIns="38100" tIns="25400" bIns="25400"/>
-                    <a:lstStyle/>
-                    <a:p>
-                      <a:pPr algn="ctr"/>
-                      <a:r>
-                        <a:rPr sz="750" b="0">
-                          <a:solidFill>
-                            <a:srgbClr val="1A1A2E"/>
-                          </a:solidFill>
-                          <a:latin typeface="Calibri"/>
-                        </a:rPr>
-                        <a:t>HTTP agent</a:t>
-                      </a:r>
-                    </a:p>
-                  </a:txBody>
-                  <a:tcPr>
-                    <a:solidFill>
-                      <a:srgbClr val="F5F8FC"/>
-                    </a:solidFill>
-                  </a:tcPr>
-                </a:tc>
-                <a:tc>
-                  <a:txBody>
-                    <a:bodyPr wrap="none" lIns="38100" rIns="38100" tIns="25400" bIns="25400"/>
-                    <a:lstStyle/>
-                    <a:p>
-                      <a:pPr algn="ctr"/>
-                      <a:r>
-                        <a:rPr sz="750" b="0">
-                          <a:solidFill>
-                            <a:srgbClr val="1A1A2E"/>
-                          </a:solidFill>
-                          <a:latin typeface="Calibri"/>
-                        </a:rPr>
-                        <a:t>API 心跳</a:t>
-                      </a:r>
-                    </a:p>
-                  </a:txBody>
-                  <a:tcPr>
-                    <a:solidFill>
-                      <a:srgbClr val="F5F8FC"/>
-                    </a:solidFill>
-                  </a:tcPr>
-                </a:tc>
-                <a:tc>
-                  <a:txBody>
-                    <a:bodyPr wrap="none" lIns="38100" rIns="38100" tIns="25400" bIns="25400"/>
-                    <a:lstStyle/>
-                    <a:p>
-                      <a:pPr algn="ctr"/>
-                      <a:r>
-                        <a:rPr sz="750" b="0">
-                          <a:solidFill>
-                            <a:srgbClr val="1A1A2E"/>
-                          </a:solidFill>
-                          <a:latin typeface="Calibri"/>
-                        </a:rPr>
-                        <a:t>巡检 / 重启 / 重部署</a:t>
-                      </a:r>
-                    </a:p>
-                  </a:txBody>
-                  <a:tcPr>
-                    <a:solidFill>
-                      <a:srgbClr val="F5F8FC"/>
-                    </a:solidFill>
-                  </a:tcPr>
-                </a:tc>
-                <a:tc>
-                  <a:txBody>
-                    <a:bodyPr wrap="none" lIns="38100" rIns="38100" tIns="25400" bIns="25400"/>
-                    <a:lstStyle/>
-                    <a:p>
-                      <a:pPr algn="ctr"/>
-                      <a:r>
-                        <a:rPr sz="750" b="0">
-                          <a:solidFill>
-                            <a:srgbClr val="1A1A2E"/>
-                          </a:solidFill>
-                          <a:latin typeface="Calibri"/>
-                        </a:rPr>
-                        <a:t>API Resend</a:t>
-                      </a:r>
-                    </a:p>
-                  </a:txBody>
-                  <a:tcPr>
-                    <a:solidFill>
-                      <a:srgbClr val="F5F8FC"/>
                     </a:solidFill>
                   </a:tcPr>
                 </a:tc>
@@ -4795,8 +4192,8 @@
         </p:nvSpPr>
         <p:spPr>
           <a:xfrm>
-            <a:off x="164592" y="3685032"/>
-            <a:ext cx="5848959" cy="256032"/>
+            <a:off x="164592" y="3611880"/>
+            <a:ext cx="11862511" cy="256032"/>
           </a:xfrm>
           <a:prstGeom prst="rect">
             <a:avLst/>
@@ -4838,8 +4235,8 @@
         </p:nvSpPr>
         <p:spPr>
           <a:xfrm>
-            <a:off x="256032" y="3703320"/>
-            <a:ext cx="5666079" cy="219456"/>
+            <a:off x="256032" y="3630168"/>
+            <a:ext cx="11679631" cy="219456"/>
           </a:xfrm>
           <a:prstGeom prst="rect">
             <a:avLst/>
@@ -4860,7 +4257,7 @@
                 </a:solidFill>
                 <a:latin typeface="Calibri"/>
               </a:rPr>
-              <a:t>🔧  核心能力矩阵</a:t>
+              <a:t>设备类型覆盖与核心能力矩阵（7 类）</a:t>
             </a:r>
           </a:p>
         </p:txBody>
@@ -4874,8 +4271,8 @@
           <p:nvPr/>
         </p:nvGraphicFramePr>
         <p:xfrm>
-          <a:off x="164592" y="3968496"/>
-          <a:ext cx="5848956" cy="2340864"/>
+          <a:off x="164592" y="3895344"/>
+          <a:ext cx="11862511" cy="2542032"/>
         </p:xfrm>
         <a:graphic>
           <a:graphicData uri="http://schemas.openxmlformats.org/drawingml/2006/table">
@@ -4884,144 +4281,1332 @@
                 <a:tableStyleId>{5C22544A-7EE6-4342-B048-85BDC9FD1C3A}</a:tableStyleId>
               </a:tblPr>
               <a:tblGrid>
-                <a:gridCol w="914400"/>
-                <a:gridCol w="1233639"/>
-                <a:gridCol w="1233639"/>
-                <a:gridCol w="1233639"/>
-                <a:gridCol w="1233639"/>
+                <a:gridCol w="1078992"/>
+                <a:gridCol w="1207008"/>
+                <a:gridCol w="1417320"/>
+                <a:gridCol w="804672"/>
+                <a:gridCol w="804672"/>
+                <a:gridCol w="896112"/>
+                <a:gridCol w="804672"/>
+                <a:gridCol w="4849063"/>
               </a:tblGrid>
-              <a:tr h="292608">
-                <a:tc>
-                  <a:txBody>
-                    <a:bodyPr wrap="none" lIns="38100" rIns="38100" tIns="25400" bIns="25400"/>
+              <a:tr h="317754">
+                <a:tc>
+                  <a:txBody>
+                    <a:bodyPr wrap="none" lIns="50800" rIns="50800" tIns="25400" bIns="25400"/>
+                    <a:lstStyle/>
+                    <a:p>
+                      <a:pPr algn="l"/>
+                      <a:r>
+                        <a:rPr sz="900" b="1">
+                          <a:solidFill>
+                            <a:srgbClr val="FFFFFF"/>
+                          </a:solidFill>
+                          <a:latin typeface="Calibri"/>
+                        </a:rPr>
+                        <a:t>设备类型</a:t>
+                      </a:r>
+                    </a:p>
+                  </a:txBody>
+                  <a:tcPr>
+                    <a:solidFill>
+                      <a:srgbClr val="275EA6"/>
+                    </a:solidFill>
+                  </a:tcPr>
+                </a:tc>
+                <a:tc>
+                  <a:txBody>
+                    <a:bodyPr wrap="none" lIns="50800" rIns="50800" tIns="25400" bIns="25400"/>
+                    <a:lstStyle/>
+                    <a:p>
+                      <a:pPr algn="l"/>
+                      <a:r>
+                        <a:rPr sz="900" b="1">
+                          <a:solidFill>
+                            <a:srgbClr val="FFFFFF"/>
+                          </a:solidFill>
+                          <a:latin typeface="Calibri"/>
+                        </a:rPr>
+                        <a:t>管控对象</a:t>
+                      </a:r>
+                    </a:p>
+                  </a:txBody>
+                  <a:tcPr>
+                    <a:solidFill>
+                      <a:srgbClr val="275EA6"/>
+                    </a:solidFill>
+                  </a:tcPr>
+                </a:tc>
+                <a:tc>
+                  <a:txBody>
+                    <a:bodyPr wrap="none" lIns="50800" rIns="50800" tIns="25400" bIns="25400"/>
+                    <a:lstStyle/>
+                    <a:p>
+                      <a:pPr algn="l"/>
+                      <a:r>
+                        <a:rPr sz="900" b="1">
+                          <a:solidFill>
+                            <a:srgbClr val="FFFFFF"/>
+                          </a:solidFill>
+                          <a:latin typeface="Calibri"/>
+                        </a:rPr>
+                        <a:t>状态检测</a:t>
+                      </a:r>
+                    </a:p>
+                  </a:txBody>
+                  <a:tcPr>
+                    <a:solidFill>
+                      <a:srgbClr val="275EA6"/>
+                    </a:solidFill>
+                  </a:tcPr>
+                </a:tc>
+                <a:tc>
+                  <a:txBody>
+                    <a:bodyPr wrap="none" lIns="50800" rIns="50800" tIns="25400" bIns="25400"/>
                     <a:lstStyle/>
                     <a:p>
                       <a:pPr algn="ctr"/>
                       <a:r>
+                        <a:rPr sz="900" b="1">
+                          <a:solidFill>
+                            <a:srgbClr val="FFFFFF"/>
+                          </a:solidFill>
+                          <a:latin typeface="Calibri"/>
+                        </a:rPr>
+                        <a:t>巡检</a:t>
+                      </a:r>
+                    </a:p>
+                  </a:txBody>
+                  <a:tcPr>
+                    <a:solidFill>
+                      <a:srgbClr val="275EA6"/>
+                    </a:solidFill>
+                  </a:tcPr>
+                </a:tc>
+                <a:tc>
+                  <a:txBody>
+                    <a:bodyPr wrap="none" lIns="50800" rIns="50800" tIns="25400" bIns="25400"/>
+                    <a:lstStyle/>
+                    <a:p>
+                      <a:pPr algn="ctr"/>
+                      <a:r>
+                        <a:rPr sz="900" b="1">
+                          <a:solidFill>
+                            <a:srgbClr val="FFFFFF"/>
+                          </a:solidFill>
+                          <a:latin typeface="Calibri"/>
+                        </a:rPr>
+                        <a:t>重启</a:t>
+                      </a:r>
+                    </a:p>
+                  </a:txBody>
+                  <a:tcPr>
+                    <a:solidFill>
+                      <a:srgbClr val="275EA6"/>
+                    </a:solidFill>
+                  </a:tcPr>
+                </a:tc>
+                <a:tc>
+                  <a:txBody>
+                    <a:bodyPr wrap="none" lIns="50800" rIns="50800" tIns="25400" bIns="25400"/>
+                    <a:lstStyle/>
+                    <a:p>
+                      <a:pPr algn="ctr"/>
+                      <a:r>
+                        <a:rPr sz="900" b="1">
+                          <a:solidFill>
+                            <a:srgbClr val="FFFFFF"/>
+                          </a:solidFill>
+                          <a:latin typeface="Calibri"/>
+                        </a:rPr>
+                        <a:t>重部署</a:t>
+                      </a:r>
+                    </a:p>
+                  </a:txBody>
+                  <a:tcPr>
+                    <a:solidFill>
+                      <a:srgbClr val="275EA6"/>
+                    </a:solidFill>
+                  </a:tcPr>
+                </a:tc>
+                <a:tc>
+                  <a:txBody>
+                    <a:bodyPr wrap="none" lIns="50800" rIns="50800" tIns="25400" bIns="25400"/>
+                    <a:lstStyle/>
+                    <a:p>
+                      <a:pPr algn="ctr"/>
+                      <a:r>
+                        <a:rPr sz="900" b="1">
+                          <a:solidFill>
+                            <a:srgbClr val="FFFFFF"/>
+                          </a:solidFill>
+                          <a:latin typeface="Calibri"/>
+                        </a:rPr>
+                        <a:t>重发</a:t>
+                      </a:r>
+                    </a:p>
+                  </a:txBody>
+                  <a:tcPr>
+                    <a:solidFill>
+                      <a:srgbClr val="275EA6"/>
+                    </a:solidFill>
+                  </a:tcPr>
+                </a:tc>
+                <a:tc>
+                  <a:txBody>
+                    <a:bodyPr wrap="none" lIns="50800" rIns="50800" tIns="25400" bIns="25400"/>
+                    <a:lstStyle/>
+                    <a:p>
+                      <a:pPr algn="l"/>
+                      <a:r>
+                        <a:rPr sz="900" b="1">
+                          <a:solidFill>
+                            <a:srgbClr val="FFFFFF"/>
+                          </a:solidFill>
+                          <a:latin typeface="Calibri"/>
+                        </a:rPr>
+                        <a:t>重传方式</a:t>
+                      </a:r>
+                    </a:p>
+                  </a:txBody>
+                  <a:tcPr>
+                    <a:solidFill>
+                      <a:srgbClr val="275EA6"/>
+                    </a:solidFill>
+                  </a:tcPr>
+                </a:tc>
+              </a:tr>
+              <a:tr h="317754">
+                <a:tc>
+                  <a:txBody>
+                    <a:bodyPr wrap="none" lIns="50800" rIns="50800" tIns="25400" bIns="25400"/>
+                    <a:lstStyle/>
+                    <a:p>
+                      <a:pPr algn="l"/>
+                      <a:r>
                         <a:rPr sz="850" b="1">
                           <a:solidFill>
                             <a:srgbClr val="FFFFFF"/>
                           </a:solidFill>
                           <a:latin typeface="Calibri"/>
                         </a:rPr>
-                        <a:t/>
-                      </a:r>
-                    </a:p>
-                  </a:txBody>
-                  <a:tcPr>
-                    <a:solidFill>
-                      <a:srgbClr val="275EA6"/>
-                    </a:solidFill>
-                  </a:tcPr>
-                </a:tc>
-                <a:tc>
-                  <a:txBody>
-                    <a:bodyPr wrap="none" lIns="38100" rIns="38100" tIns="25400" bIns="25400"/>
+                        <a:t>NEWARE</a:t>
+                      </a:r>
+                    </a:p>
+                  </a:txBody>
+                  <a:tcPr>
+                    <a:solidFill>
+                      <a:srgbClr val="1A3A6B"/>
+                    </a:solidFill>
+                  </a:tcPr>
+                </a:tc>
+                <a:tc>
+                  <a:txBody>
+                    <a:bodyPr wrap="none" lIns="50800" rIns="50800" tIns="25400" bIns="25400"/>
+                    <a:lstStyle/>
+                    <a:p>
+                      <a:pPr algn="l"/>
+                      <a:r>
+                        <a:rPr sz="850" b="0">
+                          <a:solidFill>
+                            <a:srgbClr val="1A1A2E"/>
+                          </a:solidFill>
+                          <a:latin typeface="Calibri"/>
+                        </a:rPr>
+                        <a:t>uu.exe</a:t>
+                      </a:r>
+                    </a:p>
+                  </a:txBody>
+                  <a:tcPr>
+                    <a:solidFill>
+                      <a:srgbClr val="F5F8FC"/>
+                    </a:solidFill>
+                  </a:tcPr>
+                </a:tc>
+                <a:tc>
+                  <a:txBody>
+                    <a:bodyPr wrap="none" lIns="50800" rIns="50800" tIns="25400" bIns="25400"/>
+                    <a:lstStyle/>
+                    <a:p>
+                      <a:pPr algn="l"/>
+                      <a:r>
+                        <a:rPr sz="850" b="0">
+                          <a:solidFill>
+                            <a:srgbClr val="1A1A2E"/>
+                          </a:solidFill>
+                          <a:latin typeface="Calibri"/>
+                        </a:rPr>
+                        <a:t>进程 + API</a:t>
+                      </a:r>
+                    </a:p>
+                  </a:txBody>
+                  <a:tcPr>
+                    <a:solidFill>
+                      <a:srgbClr val="F5F8FC"/>
+                    </a:solidFill>
+                  </a:tcPr>
+                </a:tc>
+                <a:tc>
+                  <a:txBody>
+                    <a:bodyPr wrap="none" lIns="50800" rIns="50800" tIns="25400" bIns="25400"/>
                     <a:lstStyle/>
                     <a:p>
                       <a:pPr algn="ctr"/>
                       <a:r>
+                        <a:rPr sz="850" b="0">
+                          <a:solidFill>
+                            <a:srgbClr val="1A8A4A"/>
+                          </a:solidFill>
+                          <a:latin typeface="Calibri"/>
+                        </a:rPr>
+                        <a:t>✓</a:t>
+                      </a:r>
+                    </a:p>
+                  </a:txBody>
+                  <a:tcPr>
+                    <a:solidFill>
+                      <a:srgbClr val="F5F8FC"/>
+                    </a:solidFill>
+                  </a:tcPr>
+                </a:tc>
+                <a:tc>
+                  <a:txBody>
+                    <a:bodyPr wrap="none" lIns="50800" rIns="50800" tIns="25400" bIns="25400"/>
+                    <a:lstStyle/>
+                    <a:p>
+                      <a:pPr algn="ctr"/>
+                      <a:r>
+                        <a:rPr sz="850" b="0">
+                          <a:solidFill>
+                            <a:srgbClr val="1A8A4A"/>
+                          </a:solidFill>
+                          <a:latin typeface="Calibri"/>
+                        </a:rPr>
+                        <a:t>✓</a:t>
+                      </a:r>
+                    </a:p>
+                  </a:txBody>
+                  <a:tcPr>
+                    <a:solidFill>
+                      <a:srgbClr val="F5F8FC"/>
+                    </a:solidFill>
+                  </a:tcPr>
+                </a:tc>
+                <a:tc>
+                  <a:txBody>
+                    <a:bodyPr wrap="none" lIns="50800" rIns="50800" tIns="25400" bIns="25400"/>
+                    <a:lstStyle/>
+                    <a:p>
+                      <a:pPr algn="ctr"/>
+                      <a:r>
+                        <a:rPr sz="850" b="0">
+                          <a:solidFill>
+                            <a:srgbClr val="1A8A4A"/>
+                          </a:solidFill>
+                          <a:latin typeface="Calibri"/>
+                        </a:rPr>
+                        <a:t>✓</a:t>
+                      </a:r>
+                    </a:p>
+                  </a:txBody>
+                  <a:tcPr>
+                    <a:solidFill>
+                      <a:srgbClr val="F5F8FC"/>
+                    </a:solidFill>
+                  </a:tcPr>
+                </a:tc>
+                <a:tc>
+                  <a:txBody>
+                    <a:bodyPr wrap="none" lIns="50800" rIns="50800" tIns="25400" bIns="25400"/>
+                    <a:lstStyle/>
+                    <a:p>
+                      <a:pPr algn="ctr"/>
+                      <a:r>
+                        <a:rPr sz="850" b="0">
+                          <a:solidFill>
+                            <a:srgbClr val="55657A"/>
+                          </a:solidFill>
+                          <a:latin typeface="Calibri"/>
+                        </a:rPr>
+                        <a:t>—</a:t>
+                      </a:r>
+                    </a:p>
+                  </a:txBody>
+                  <a:tcPr>
+                    <a:solidFill>
+                      <a:srgbClr val="F5F8FC"/>
+                    </a:solidFill>
+                  </a:tcPr>
+                </a:tc>
+                <a:tc>
+                  <a:txBody>
+                    <a:bodyPr wrap="none" lIns="50800" rIns="50800" tIns="25400" bIns="25400"/>
+                    <a:lstStyle/>
+                    <a:p>
+                      <a:pPr algn="l"/>
+                      <a:r>
+                        <a:rPr sz="850" b="0">
+                          <a:solidFill>
+                            <a:srgbClr val="1A1A2E"/>
+                          </a:solidFill>
+                          <a:latin typeface="Calibri"/>
+                        </a:rPr>
+                        <a:t>配置字段（INI）</a:t>
+                      </a:r>
+                    </a:p>
+                  </a:txBody>
+                  <a:tcPr>
+                    <a:solidFill>
+                      <a:srgbClr val="F5F8FC"/>
+                    </a:solidFill>
+                  </a:tcPr>
+                </a:tc>
+              </a:tr>
+              <a:tr h="317754">
+                <a:tc>
+                  <a:txBody>
+                    <a:bodyPr wrap="none" lIns="50800" rIns="50800" tIns="25400" bIns="25400"/>
+                    <a:lstStyle/>
+                    <a:p>
+                      <a:pPr algn="l"/>
+                      <a:r>
                         <a:rPr sz="850" b="1">
                           <a:solidFill>
                             <a:srgbClr val="FFFFFF"/>
                           </a:solidFill>
                           <a:latin typeface="Calibri"/>
                         </a:rPr>
-                        <a:t>Patrol</a:t>
-                      </a:r>
-                    </a:p>
-                  </a:txBody>
-                  <a:tcPr>
-                    <a:solidFill>
-                      <a:srgbClr val="275EA6"/>
-                    </a:solidFill>
-                  </a:tcPr>
-                </a:tc>
-                <a:tc>
-                  <a:txBody>
-                    <a:bodyPr wrap="none" lIns="38100" rIns="38100" tIns="25400" bIns="25400"/>
+                        <a:t>LAND</a:t>
+                      </a:r>
+                    </a:p>
+                  </a:txBody>
+                  <a:tcPr>
+                    <a:solidFill>
+                      <a:srgbClr val="1A3A6B"/>
+                    </a:solidFill>
+                  </a:tcPr>
+                </a:tc>
+                <a:tc>
+                  <a:txBody>
+                    <a:bodyPr wrap="none" lIns="50800" rIns="50800" tIns="25400" bIns="25400"/>
+                    <a:lstStyle/>
+                    <a:p>
+                      <a:pPr algn="l"/>
+                      <a:r>
+                        <a:rPr sz="850" b="0">
+                          <a:solidFill>
+                            <a:srgbClr val="1A1A2E"/>
+                          </a:solidFill>
+                          <a:latin typeface="Calibri"/>
+                        </a:rPr>
+                        <a:t>LHBTS.exe</a:t>
+                      </a:r>
+                    </a:p>
+                  </a:txBody>
+                  <a:tcPr>
+                    <a:solidFill>
+                      <a:srgbClr val="EBF3FB"/>
+                    </a:solidFill>
+                  </a:tcPr>
+                </a:tc>
+                <a:tc>
+                  <a:txBody>
+                    <a:bodyPr wrap="none" lIns="50800" rIns="50800" tIns="25400" bIns="25400"/>
+                    <a:lstStyle/>
+                    <a:p>
+                      <a:pPr algn="l"/>
+                      <a:r>
+                        <a:rPr sz="850" b="0">
+                          <a:solidFill>
+                            <a:srgbClr val="1A3A6B"/>
+                          </a:solidFill>
+                          <a:latin typeface="Calibri"/>
+                        </a:rPr>
+                        <a:t>QueryStatus</a:t>
+                      </a:r>
+                    </a:p>
+                  </a:txBody>
+                  <a:tcPr>
+                    <a:solidFill>
+                      <a:srgbClr val="EBF3FB"/>
+                    </a:solidFill>
+                  </a:tcPr>
+                </a:tc>
+                <a:tc>
+                  <a:txBody>
+                    <a:bodyPr wrap="none" lIns="50800" rIns="50800" tIns="25400" bIns="25400"/>
                     <a:lstStyle/>
                     <a:p>
                       <a:pPr algn="ctr"/>
                       <a:r>
+                        <a:rPr sz="850" b="0">
+                          <a:solidFill>
+                            <a:srgbClr val="1A8A4A"/>
+                          </a:solidFill>
+                          <a:latin typeface="Calibri"/>
+                        </a:rPr>
+                        <a:t>✓</a:t>
+                      </a:r>
+                    </a:p>
+                  </a:txBody>
+                  <a:tcPr>
+                    <a:solidFill>
+                      <a:srgbClr val="EBF3FB"/>
+                    </a:solidFill>
+                  </a:tcPr>
+                </a:tc>
+                <a:tc>
+                  <a:txBody>
+                    <a:bodyPr wrap="none" lIns="50800" rIns="50800" tIns="25400" bIns="25400"/>
+                    <a:lstStyle/>
+                    <a:p>
+                      <a:pPr algn="ctr"/>
+                      <a:r>
+                        <a:rPr sz="850" b="0">
+                          <a:solidFill>
+                            <a:srgbClr val="1A8A4A"/>
+                          </a:solidFill>
+                          <a:latin typeface="Calibri"/>
+                        </a:rPr>
+                        <a:t>✓</a:t>
+                      </a:r>
+                    </a:p>
+                  </a:txBody>
+                  <a:tcPr>
+                    <a:solidFill>
+                      <a:srgbClr val="EBF3FB"/>
+                    </a:solidFill>
+                  </a:tcPr>
+                </a:tc>
+                <a:tc>
+                  <a:txBody>
+                    <a:bodyPr wrap="none" lIns="50800" rIns="50800" tIns="25400" bIns="25400"/>
+                    <a:lstStyle/>
+                    <a:p>
+                      <a:pPr algn="ctr"/>
+                      <a:r>
+                        <a:rPr sz="850" b="0">
+                          <a:solidFill>
+                            <a:srgbClr val="1A8A4A"/>
+                          </a:solidFill>
+                          <a:latin typeface="Calibri"/>
+                        </a:rPr>
+                        <a:t>✓</a:t>
+                      </a:r>
+                    </a:p>
+                  </a:txBody>
+                  <a:tcPr>
+                    <a:solidFill>
+                      <a:srgbClr val="EBF3FB"/>
+                    </a:solidFill>
+                  </a:tcPr>
+                </a:tc>
+                <a:tc>
+                  <a:txBody>
+                    <a:bodyPr wrap="none" lIns="50800" rIns="50800" tIns="25400" bIns="25400"/>
+                    <a:lstStyle/>
+                    <a:p>
+                      <a:pPr algn="ctr"/>
+                      <a:r>
+                        <a:rPr sz="850" b="0">
+                          <a:solidFill>
+                            <a:srgbClr val="1A8A4A"/>
+                          </a:solidFill>
+                          <a:latin typeface="Calibri"/>
+                        </a:rPr>
+                        <a:t>✓</a:t>
+                      </a:r>
+                    </a:p>
+                  </a:txBody>
+                  <a:tcPr>
+                    <a:solidFill>
+                      <a:srgbClr val="EBF3FB"/>
+                    </a:solidFill>
+                  </a:tcPr>
+                </a:tc>
+                <a:tc>
+                  <a:txBody>
+                    <a:bodyPr wrap="none" lIns="50800" rIns="50800" tIns="25400" bIns="25400"/>
+                    <a:lstStyle/>
+                    <a:p>
+                      <a:pPr algn="l"/>
+                      <a:r>
+                        <a:rPr sz="850" b="0">
+                          <a:solidFill>
+                            <a:srgbClr val="1A1A2E"/>
+                          </a:solidFill>
+                          <a:latin typeface="Calibri"/>
+                        </a:rPr>
+                        <a:t>Redeliver</a:t>
+                      </a:r>
+                    </a:p>
+                  </a:txBody>
+                  <a:tcPr>
+                    <a:solidFill>
+                      <a:srgbClr val="EBF3FB"/>
+                    </a:solidFill>
+                  </a:tcPr>
+                </a:tc>
+              </a:tr>
+              <a:tr h="317754">
+                <a:tc>
+                  <a:txBody>
+                    <a:bodyPr wrap="none" lIns="50800" rIns="50800" tIns="25400" bIns="25400"/>
+                    <a:lstStyle/>
+                    <a:p>
+                      <a:pPr algn="l"/>
+                      <a:r>
                         <a:rPr sz="850" b="1">
                           <a:solidFill>
                             <a:srgbClr val="FFFFFF"/>
                           </a:solidFill>
                           <a:latin typeface="Calibri"/>
                         </a:rPr>
-                        <a:t>Restart</a:t>
-                      </a:r>
-                    </a:p>
-                  </a:txBody>
-                  <a:tcPr>
-                    <a:solidFill>
-                      <a:srgbClr val="275EA6"/>
-                    </a:solidFill>
-                  </a:tcPr>
-                </a:tc>
-                <a:tc>
-                  <a:txBody>
-                    <a:bodyPr wrap="none" lIns="38100" rIns="38100" tIns="25400" bIns="25400"/>
+                        <a:t>LANH</a:t>
+                      </a:r>
+                    </a:p>
+                  </a:txBody>
+                  <a:tcPr>
+                    <a:solidFill>
+                      <a:srgbClr val="1A3A6B"/>
+                    </a:solidFill>
+                  </a:tcPr>
+                </a:tc>
+                <a:tc>
+                  <a:txBody>
+                    <a:bodyPr wrap="none" lIns="50800" rIns="50800" tIns="25400" bIns="25400"/>
+                    <a:lstStyle/>
+                    <a:p>
+                      <a:pPr algn="l"/>
+                      <a:r>
+                        <a:rPr sz="850" b="0">
+                          <a:solidFill>
+                            <a:srgbClr val="1A1A2E"/>
+                          </a:solidFill>
+                          <a:latin typeface="Calibri"/>
+                        </a:rPr>
+                        <a:t>ccsmon.exe</a:t>
+                      </a:r>
+                    </a:p>
+                  </a:txBody>
+                  <a:tcPr>
+                    <a:solidFill>
+                      <a:srgbClr val="F5F8FC"/>
+                    </a:solidFill>
+                  </a:tcPr>
+                </a:tc>
+                <a:tc>
+                  <a:txBody>
+                    <a:bodyPr wrap="none" lIns="50800" rIns="50800" tIns="25400" bIns="25400"/>
+                    <a:lstStyle/>
+                    <a:p>
+                      <a:pPr algn="l"/>
+                      <a:r>
+                        <a:rPr sz="850" b="0">
+                          <a:solidFill>
+                            <a:srgbClr val="1A3A6B"/>
+                          </a:solidFill>
+                          <a:latin typeface="Calibri"/>
+                        </a:rPr>
+                        <a:t>QueryStatus</a:t>
+                      </a:r>
+                    </a:p>
+                  </a:txBody>
+                  <a:tcPr>
+                    <a:solidFill>
+                      <a:srgbClr val="F5F8FC"/>
+                    </a:solidFill>
+                  </a:tcPr>
+                </a:tc>
+                <a:tc>
+                  <a:txBody>
+                    <a:bodyPr wrap="none" lIns="50800" rIns="50800" tIns="25400" bIns="25400"/>
                     <a:lstStyle/>
                     <a:p>
                       <a:pPr algn="ctr"/>
                       <a:r>
+                        <a:rPr sz="850" b="0">
+                          <a:solidFill>
+                            <a:srgbClr val="1A8A4A"/>
+                          </a:solidFill>
+                          <a:latin typeface="Calibri"/>
+                        </a:rPr>
+                        <a:t>✓</a:t>
+                      </a:r>
+                    </a:p>
+                  </a:txBody>
+                  <a:tcPr>
+                    <a:solidFill>
+                      <a:srgbClr val="F5F8FC"/>
+                    </a:solidFill>
+                  </a:tcPr>
+                </a:tc>
+                <a:tc>
+                  <a:txBody>
+                    <a:bodyPr wrap="none" lIns="50800" rIns="50800" tIns="25400" bIns="25400"/>
+                    <a:lstStyle/>
+                    <a:p>
+                      <a:pPr algn="ctr"/>
+                      <a:r>
+                        <a:rPr sz="850" b="0">
+                          <a:solidFill>
+                            <a:srgbClr val="55657A"/>
+                          </a:solidFill>
+                          <a:latin typeface="Calibri"/>
+                        </a:rPr>
+                        <a:t>—</a:t>
+                      </a:r>
+                    </a:p>
+                  </a:txBody>
+                  <a:tcPr>
+                    <a:solidFill>
+                      <a:srgbClr val="F5F8FC"/>
+                    </a:solidFill>
+                  </a:tcPr>
+                </a:tc>
+                <a:tc>
+                  <a:txBody>
+                    <a:bodyPr wrap="none" lIns="50800" rIns="50800" tIns="25400" bIns="25400"/>
+                    <a:lstStyle/>
+                    <a:p>
+                      <a:pPr algn="ctr"/>
+                      <a:r>
+                        <a:rPr sz="850" b="0">
+                          <a:solidFill>
+                            <a:srgbClr val="55657A"/>
+                          </a:solidFill>
+                          <a:latin typeface="Calibri"/>
+                        </a:rPr>
+                        <a:t>—</a:t>
+                      </a:r>
+                    </a:p>
+                  </a:txBody>
+                  <a:tcPr>
+                    <a:solidFill>
+                      <a:srgbClr val="F5F8FC"/>
+                    </a:solidFill>
+                  </a:tcPr>
+                </a:tc>
+                <a:tc>
+                  <a:txBody>
+                    <a:bodyPr wrap="none" lIns="50800" rIns="50800" tIns="25400" bIns="25400"/>
+                    <a:lstStyle/>
+                    <a:p>
+                      <a:pPr algn="ctr"/>
+                      <a:r>
+                        <a:rPr sz="850" b="0">
+                          <a:solidFill>
+                            <a:srgbClr val="1A8A4A"/>
+                          </a:solidFill>
+                          <a:latin typeface="Calibri"/>
+                        </a:rPr>
+                        <a:t>✓</a:t>
+                      </a:r>
+                    </a:p>
+                  </a:txBody>
+                  <a:tcPr>
+                    <a:solidFill>
+                      <a:srgbClr val="F5F8FC"/>
+                    </a:solidFill>
+                  </a:tcPr>
+                </a:tc>
+                <a:tc>
+                  <a:txBody>
+                    <a:bodyPr wrap="none" lIns="50800" rIns="50800" tIns="25400" bIns="25400"/>
+                    <a:lstStyle/>
+                    <a:p>
+                      <a:pPr algn="l"/>
+                      <a:r>
+                        <a:rPr sz="850" b="0">
+                          <a:solidFill>
+                            <a:srgbClr val="1A1A2E"/>
+                          </a:solidFill>
+                          <a:latin typeface="Calibri"/>
+                        </a:rPr>
+                        <a:t>Redeliver</a:t>
+                      </a:r>
+                    </a:p>
+                  </a:txBody>
+                  <a:tcPr>
+                    <a:solidFill>
+                      <a:srgbClr val="F5F8FC"/>
+                    </a:solidFill>
+                  </a:tcPr>
+                </a:tc>
+              </a:tr>
+              <a:tr h="317754">
+                <a:tc>
+                  <a:txBody>
+                    <a:bodyPr wrap="none" lIns="50800" rIns="50800" tIns="25400" bIns="25400"/>
+                    <a:lstStyle/>
+                    <a:p>
+                      <a:pPr algn="l"/>
+                      <a:r>
                         <a:rPr sz="850" b="1">
                           <a:solidFill>
                             <a:srgbClr val="FFFFFF"/>
                           </a:solidFill>
                           <a:latin typeface="Calibri"/>
                         </a:rPr>
-                        <a:t>Redeploy</a:t>
-                      </a:r>
-                    </a:p>
-                  </a:txBody>
-                  <a:tcPr>
-                    <a:solidFill>
-                      <a:srgbClr val="275EA6"/>
-                    </a:solidFill>
-                  </a:tcPr>
-                </a:tc>
-                <a:tc>
-                  <a:txBody>
-                    <a:bodyPr wrap="none" lIns="38100" rIns="38100" tIns="25400" bIns="25400"/>
+                        <a:t>SINEXCEL</a:t>
+                      </a:r>
+                    </a:p>
+                  </a:txBody>
+                  <a:tcPr>
+                    <a:solidFill>
+                      <a:srgbClr val="1A3A6B"/>
+                    </a:solidFill>
+                  </a:tcPr>
+                </a:tc>
+                <a:tc>
+                  <a:txBody>
+                    <a:bodyPr wrap="none" lIns="50800" rIns="50800" tIns="25400" bIns="25400"/>
+                    <a:lstStyle/>
+                    <a:p>
+                      <a:pPr algn="l"/>
+                      <a:r>
+                        <a:rPr sz="850" b="0">
+                          <a:solidFill>
+                            <a:srgbClr val="1A1A2E"/>
+                          </a:solidFill>
+                          <a:latin typeface="Calibri"/>
+                        </a:rPr>
+                        <a:t>agent.exe</a:t>
+                      </a:r>
+                    </a:p>
+                  </a:txBody>
+                  <a:tcPr>
+                    <a:solidFill>
+                      <a:srgbClr val="EBF3FB"/>
+                    </a:solidFill>
+                  </a:tcPr>
+                </a:tc>
+                <a:tc>
+                  <a:txBody>
+                    <a:bodyPr wrap="none" lIns="50800" rIns="50800" tIns="25400" bIns="25400"/>
+                    <a:lstStyle/>
+                    <a:p>
+                      <a:pPr algn="l"/>
+                      <a:r>
+                        <a:rPr sz="850" b="0">
+                          <a:solidFill>
+                            <a:srgbClr val="1A3A6B"/>
+                          </a:solidFill>
+                          <a:latin typeface="Calibri"/>
+                        </a:rPr>
+                        <a:t>QueryConfig</a:t>
+                      </a:r>
+                    </a:p>
+                  </a:txBody>
+                  <a:tcPr>
+                    <a:solidFill>
+                      <a:srgbClr val="EBF3FB"/>
+                    </a:solidFill>
+                  </a:tcPr>
+                </a:tc>
+                <a:tc>
+                  <a:txBody>
+                    <a:bodyPr wrap="none" lIns="50800" rIns="50800" tIns="25400" bIns="25400"/>
                     <a:lstStyle/>
                     <a:p>
                       <a:pPr algn="ctr"/>
                       <a:r>
+                        <a:rPr sz="850" b="0">
+                          <a:solidFill>
+                            <a:srgbClr val="1A8A4A"/>
+                          </a:solidFill>
+                          <a:latin typeface="Calibri"/>
+                        </a:rPr>
+                        <a:t>✓</a:t>
+                      </a:r>
+                    </a:p>
+                  </a:txBody>
+                  <a:tcPr>
+                    <a:solidFill>
+                      <a:srgbClr val="EBF3FB"/>
+                    </a:solidFill>
+                  </a:tcPr>
+                </a:tc>
+                <a:tc>
+                  <a:txBody>
+                    <a:bodyPr wrap="none" lIns="50800" rIns="50800" tIns="25400" bIns="25400"/>
+                    <a:lstStyle/>
+                    <a:p>
+                      <a:pPr algn="ctr"/>
+                      <a:r>
+                        <a:rPr sz="850" b="0">
+                          <a:solidFill>
+                            <a:srgbClr val="1A8A4A"/>
+                          </a:solidFill>
+                          <a:latin typeface="Calibri"/>
+                        </a:rPr>
+                        <a:t>✓</a:t>
+                      </a:r>
+                    </a:p>
+                  </a:txBody>
+                  <a:tcPr>
+                    <a:solidFill>
+                      <a:srgbClr val="EBF3FB"/>
+                    </a:solidFill>
+                  </a:tcPr>
+                </a:tc>
+                <a:tc>
+                  <a:txBody>
+                    <a:bodyPr wrap="none" lIns="50800" rIns="50800" tIns="25400" bIns="25400"/>
+                    <a:lstStyle/>
+                    <a:p>
+                      <a:pPr algn="ctr"/>
+                      <a:r>
+                        <a:rPr sz="850" b="0">
+                          <a:solidFill>
+                            <a:srgbClr val="1A8A4A"/>
+                          </a:solidFill>
+                          <a:latin typeface="Calibri"/>
+                        </a:rPr>
+                        <a:t>✓</a:t>
+                      </a:r>
+                    </a:p>
+                  </a:txBody>
+                  <a:tcPr>
+                    <a:solidFill>
+                      <a:srgbClr val="EBF3FB"/>
+                    </a:solidFill>
+                  </a:tcPr>
+                </a:tc>
+                <a:tc>
+                  <a:txBody>
+                    <a:bodyPr wrap="none" lIns="50800" rIns="50800" tIns="25400" bIns="25400"/>
+                    <a:lstStyle/>
+                    <a:p>
+                      <a:pPr algn="ctr"/>
+                      <a:r>
+                        <a:rPr sz="850" b="0">
+                          <a:solidFill>
+                            <a:srgbClr val="1A8A4A"/>
+                          </a:solidFill>
+                          <a:latin typeface="Calibri"/>
+                        </a:rPr>
+                        <a:t>✓</a:t>
+                      </a:r>
+                    </a:p>
+                  </a:txBody>
+                  <a:tcPr>
+                    <a:solidFill>
+                      <a:srgbClr val="EBF3FB"/>
+                    </a:solidFill>
+                  </a:tcPr>
+                </a:tc>
+                <a:tc>
+                  <a:txBody>
+                    <a:bodyPr wrap="none" lIns="50800" rIns="50800" tIns="25400" bIns="25400"/>
+                    <a:lstStyle/>
+                    <a:p>
+                      <a:pPr algn="l"/>
+                      <a:r>
+                        <a:rPr sz="850" b="0">
+                          <a:solidFill>
+                            <a:srgbClr val="1A1A2E"/>
+                          </a:solidFill>
+                          <a:latin typeface="Calibri"/>
+                        </a:rPr>
+                        <a:t>Retransmit</a:t>
+                      </a:r>
+                    </a:p>
+                  </a:txBody>
+                  <a:tcPr>
+                    <a:solidFill>
+                      <a:srgbClr val="EBF3FB"/>
+                    </a:solidFill>
+                  </a:tcPr>
+                </a:tc>
+              </a:tr>
+              <a:tr h="317754">
+                <a:tc>
+                  <a:txBody>
+                    <a:bodyPr wrap="none" lIns="50800" rIns="50800" tIns="25400" bIns="25400"/>
+                    <a:lstStyle/>
+                    <a:p>
+                      <a:pPr algn="l"/>
+                      <a:r>
                         <a:rPr sz="850" b="1">
                           <a:solidFill>
                             <a:srgbClr val="FFFFFF"/>
                           </a:solidFill>
                           <a:latin typeface="Calibri"/>
                         </a:rPr>
-                        <a:t>Resend</a:t>
-                      </a:r>
-                    </a:p>
-                  </a:txBody>
-                  <a:tcPr>
-                    <a:solidFill>
-                      <a:srgbClr val="275EA6"/>
+                        <a:t>NBT</a:t>
+                      </a:r>
+                    </a:p>
+                  </a:txBody>
+                  <a:tcPr>
+                    <a:solidFill>
+                      <a:srgbClr val="1A3A6B"/>
+                    </a:solidFill>
+                  </a:tcPr>
+                </a:tc>
+                <a:tc>
+                  <a:txBody>
+                    <a:bodyPr wrap="none" lIns="50800" rIns="50800" tIns="25400" bIns="25400"/>
+                    <a:lstStyle/>
+                    <a:p>
+                      <a:pPr algn="l"/>
+                      <a:r>
+                        <a:rPr sz="850" b="0">
+                          <a:solidFill>
+                            <a:srgbClr val="1A1A2E"/>
+                          </a:solidFill>
+                          <a:latin typeface="Calibri"/>
+                        </a:rPr>
+                        <a:t>Win 服务</a:t>
+                      </a:r>
+                    </a:p>
+                  </a:txBody>
+                  <a:tcPr>
+                    <a:solidFill>
+                      <a:srgbClr val="F5F8FC"/>
+                    </a:solidFill>
+                  </a:tcPr>
+                </a:tc>
+                <a:tc>
+                  <a:txBody>
+                    <a:bodyPr wrap="none" lIns="50800" rIns="50800" tIns="25400" bIns="25400"/>
+                    <a:lstStyle/>
+                    <a:p>
+                      <a:pPr algn="l"/>
+                      <a:r>
+                        <a:rPr sz="850" b="0">
+                          <a:solidFill>
+                            <a:srgbClr val="1A1A2E"/>
+                          </a:solidFill>
+                          <a:latin typeface="Calibri"/>
+                        </a:rPr>
+                        <a:t>服务 + 心跳</a:t>
+                      </a:r>
+                    </a:p>
+                  </a:txBody>
+                  <a:tcPr>
+                    <a:solidFill>
+                      <a:srgbClr val="F5F8FC"/>
+                    </a:solidFill>
+                  </a:tcPr>
+                </a:tc>
+                <a:tc>
+                  <a:txBody>
+                    <a:bodyPr wrap="none" lIns="50800" rIns="50800" tIns="25400" bIns="25400"/>
+                    <a:lstStyle/>
+                    <a:p>
+                      <a:pPr algn="ctr"/>
+                      <a:r>
+                        <a:rPr sz="850" b="0">
+                          <a:solidFill>
+                            <a:srgbClr val="1A8A4A"/>
+                          </a:solidFill>
+                          <a:latin typeface="Calibri"/>
+                        </a:rPr>
+                        <a:t>✓</a:t>
+                      </a:r>
+                    </a:p>
+                  </a:txBody>
+                  <a:tcPr>
+                    <a:solidFill>
+                      <a:srgbClr val="F5F8FC"/>
+                    </a:solidFill>
+                  </a:tcPr>
+                </a:tc>
+                <a:tc>
+                  <a:txBody>
+                    <a:bodyPr wrap="none" lIns="50800" rIns="50800" tIns="25400" bIns="25400"/>
+                    <a:lstStyle/>
+                    <a:p>
+                      <a:pPr algn="ctr"/>
+                      <a:r>
+                        <a:rPr sz="850" b="0">
+                          <a:solidFill>
+                            <a:srgbClr val="1A8A4A"/>
+                          </a:solidFill>
+                          <a:latin typeface="Calibri"/>
+                        </a:rPr>
+                        <a:t>✓</a:t>
+                      </a:r>
+                    </a:p>
+                  </a:txBody>
+                  <a:tcPr>
+                    <a:solidFill>
+                      <a:srgbClr val="F5F8FC"/>
+                    </a:solidFill>
+                  </a:tcPr>
+                </a:tc>
+                <a:tc>
+                  <a:txBody>
+                    <a:bodyPr wrap="none" lIns="50800" rIns="50800" tIns="25400" bIns="25400"/>
+                    <a:lstStyle/>
+                    <a:p>
+                      <a:pPr algn="ctr"/>
+                      <a:r>
+                        <a:rPr sz="850" b="0">
+                          <a:solidFill>
+                            <a:srgbClr val="1A8A4A"/>
+                          </a:solidFill>
+                          <a:latin typeface="Calibri"/>
+                        </a:rPr>
+                        <a:t>✓</a:t>
+                      </a:r>
+                    </a:p>
+                  </a:txBody>
+                  <a:tcPr>
+                    <a:solidFill>
+                      <a:srgbClr val="F5F8FC"/>
+                    </a:solidFill>
+                  </a:tcPr>
+                </a:tc>
+                <a:tc>
+                  <a:txBody>
+                    <a:bodyPr wrap="none" lIns="50800" rIns="50800" tIns="25400" bIns="25400"/>
+                    <a:lstStyle/>
+                    <a:p>
+                      <a:pPr algn="ctr"/>
+                      <a:r>
+                        <a:rPr sz="850" b="0">
+                          <a:solidFill>
+                            <a:srgbClr val="1A8A4A"/>
+                          </a:solidFill>
+                          <a:latin typeface="Calibri"/>
+                        </a:rPr>
+                        <a:t>✓</a:t>
+                      </a:r>
+                    </a:p>
+                  </a:txBody>
+                  <a:tcPr>
+                    <a:solidFill>
+                      <a:srgbClr val="F5F8FC"/>
+                    </a:solidFill>
+                  </a:tcPr>
+                </a:tc>
+                <a:tc>
+                  <a:txBody>
+                    <a:bodyPr wrap="none" lIns="50800" rIns="50800" tIns="25400" bIns="25400"/>
+                    <a:lstStyle/>
+                    <a:p>
+                      <a:pPr algn="l"/>
+                      <a:r>
+                        <a:rPr sz="850" b="0">
+                          <a:solidFill>
+                            <a:srgbClr val="1A1A2E"/>
+                          </a:solidFill>
+                          <a:latin typeface="Calibri"/>
+                        </a:rPr>
+                        <a:t>ResetData</a:t>
+                      </a:r>
+                    </a:p>
+                  </a:txBody>
+                  <a:tcPr>
+                    <a:solidFill>
+                      <a:srgbClr val="F5F8FC"/>
                     </a:solidFill>
                   </a:tcPr>
                 </a:tc>
               </a:tr>
-              <a:tr h="292608">
-                <a:tc>
-                  <a:txBody>
-                    <a:bodyPr wrap="none" lIns="38100" rIns="38100" tIns="25400" bIns="25400"/>
+              <a:tr h="317754">
+                <a:tc>
+                  <a:txBody>
+                    <a:bodyPr wrap="none" lIns="50800" rIns="50800" tIns="25400" bIns="25400"/>
+                    <a:lstStyle/>
+                    <a:p>
+                      <a:pPr algn="l"/>
+                      <a:r>
+                        <a:rPr sz="850" b="1">
+                          <a:solidFill>
+                            <a:srgbClr val="FFFFFF"/>
+                          </a:solidFill>
+                          <a:latin typeface="Calibri"/>
+                        </a:rPr>
+                        <a:t>DAHUA</a:t>
+                      </a:r>
+                    </a:p>
+                  </a:txBody>
+                  <a:tcPr>
+                    <a:solidFill>
+                      <a:srgbClr val="1A3A6B"/>
+                    </a:solidFill>
+                  </a:tcPr>
+                </a:tc>
+                <a:tc>
+                  <a:txBody>
+                    <a:bodyPr wrap="none" lIns="50800" rIns="50800" tIns="25400" bIns="25400"/>
+                    <a:lstStyle/>
+                    <a:p>
+                      <a:pPr algn="l"/>
+                      <a:r>
+                        <a:rPr sz="850" b="0">
+                          <a:solidFill>
+                            <a:srgbClr val="1A1A2E"/>
+                          </a:solidFill>
+                          <a:latin typeface="Calibri"/>
+                        </a:rPr>
+                        <a:t>lims-hist</a:t>
+                      </a:r>
+                    </a:p>
+                  </a:txBody>
+                  <a:tcPr>
+                    <a:solidFill>
+                      <a:srgbClr val="EBF3FB"/>
+                    </a:solidFill>
+                  </a:tcPr>
+                </a:tc>
+                <a:tc>
+                  <a:txBody>
+                    <a:bodyPr wrap="none" lIns="50800" rIns="50800" tIns="25400" bIns="25400"/>
+                    <a:lstStyle/>
+                    <a:p>
+                      <a:pPr algn="l"/>
+                      <a:r>
+                        <a:rPr sz="850" b="0">
+                          <a:solidFill>
+                            <a:srgbClr val="55657A"/>
+                          </a:solidFill>
+                          <a:latin typeface="Calibri"/>
+                        </a:rPr>
+                        <a:t>—</a:t>
+                      </a:r>
+                    </a:p>
+                  </a:txBody>
+                  <a:tcPr>
+                    <a:solidFill>
+                      <a:srgbClr val="EBF3FB"/>
+                    </a:solidFill>
+                  </a:tcPr>
+                </a:tc>
+                <a:tc>
+                  <a:txBody>
+                    <a:bodyPr wrap="none" lIns="50800" rIns="50800" tIns="25400" bIns="25400"/>
                     <a:lstStyle/>
                     <a:p>
                       <a:pPr algn="ctr"/>
                       <a:r>
+                        <a:rPr sz="850" b="0">
+                          <a:solidFill>
+                            <a:srgbClr val="55657A"/>
+                          </a:solidFill>
+                          <a:latin typeface="Calibri"/>
+                        </a:rPr>
+                        <a:t>—</a:t>
+                      </a:r>
+                    </a:p>
+                  </a:txBody>
+                  <a:tcPr>
+                    <a:solidFill>
+                      <a:srgbClr val="EBF3FB"/>
+                    </a:solidFill>
+                  </a:tcPr>
+                </a:tc>
+                <a:tc>
+                  <a:txBody>
+                    <a:bodyPr wrap="none" lIns="50800" rIns="50800" tIns="25400" bIns="25400"/>
+                    <a:lstStyle/>
+                    <a:p>
+                      <a:pPr algn="ctr"/>
+                      <a:r>
+                        <a:rPr sz="850" b="0">
+                          <a:solidFill>
+                            <a:srgbClr val="55657A"/>
+                          </a:solidFill>
+                          <a:latin typeface="Calibri"/>
+                        </a:rPr>
+                        <a:t>—</a:t>
+                      </a:r>
+                    </a:p>
+                  </a:txBody>
+                  <a:tcPr>
+                    <a:solidFill>
+                      <a:srgbClr val="EBF3FB"/>
+                    </a:solidFill>
+                  </a:tcPr>
+                </a:tc>
+                <a:tc>
+                  <a:txBody>
+                    <a:bodyPr wrap="none" lIns="50800" rIns="50800" tIns="25400" bIns="25400"/>
+                    <a:lstStyle/>
+                    <a:p>
+                      <a:pPr algn="ctr"/>
+                      <a:r>
+                        <a:rPr sz="850" b="0">
+                          <a:solidFill>
+                            <a:srgbClr val="55657A"/>
+                          </a:solidFill>
+                          <a:latin typeface="Calibri"/>
+                        </a:rPr>
+                        <a:t>—</a:t>
+                      </a:r>
+                    </a:p>
+                  </a:txBody>
+                  <a:tcPr>
+                    <a:solidFill>
+                      <a:srgbClr val="EBF3FB"/>
+                    </a:solidFill>
+                  </a:tcPr>
+                </a:tc>
+                <a:tc>
+                  <a:txBody>
+                    <a:bodyPr wrap="none" lIns="50800" rIns="50800" tIns="25400" bIns="25400"/>
+                    <a:lstStyle/>
+                    <a:p>
+                      <a:pPr algn="ctr"/>
+                      <a:r>
+                        <a:rPr sz="850" b="0">
+                          <a:solidFill>
+                            <a:srgbClr val="1A8A4A"/>
+                          </a:solidFill>
+                          <a:latin typeface="Calibri"/>
+                        </a:rPr>
+                        <a:t>✓</a:t>
+                      </a:r>
+                    </a:p>
+                  </a:txBody>
+                  <a:tcPr>
+                    <a:solidFill>
+                      <a:srgbClr val="EBF3FB"/>
+                    </a:solidFill>
+                  </a:tcPr>
+                </a:tc>
+                <a:tc>
+                  <a:txBody>
+                    <a:bodyPr wrap="none" lIns="50800" rIns="50800" tIns="25400" bIns="25400"/>
+                    <a:lstStyle/>
+                    <a:p>
+                      <a:pPr algn="l"/>
+                      <a:r>
+                        <a:rPr sz="850" b="0">
+                          <a:solidFill>
+                            <a:srgbClr val="1A1A2E"/>
+                          </a:solidFill>
+                          <a:latin typeface="Calibri"/>
+                        </a:rPr>
+                        <a:t>CLI 重发</a:t>
+                      </a:r>
+                    </a:p>
+                  </a:txBody>
+                  <a:tcPr>
+                    <a:solidFill>
+                      <a:srgbClr val="EBF3FB"/>
+                    </a:solidFill>
+                  </a:tcPr>
+                </a:tc>
+              </a:tr>
+              <a:tr h="317754">
+                <a:tc>
+                  <a:txBody>
+                    <a:bodyPr wrap="none" lIns="50800" rIns="50800" tIns="25400" bIns="25400"/>
+                    <a:lstStyle/>
+                    <a:p>
+                      <a:pPr algn="l"/>
+                      <a:r>
                         <a:rPr sz="850" b="1">
                           <a:solidFill>
                             <a:srgbClr val="FFFFFF"/>
                           </a:solidFill>
                           <a:latin typeface="Calibri"/>
                         </a:rPr>
-                        <a:t>NEWARE</a:t>
+                        <a:t>JHAI</a:t>
                       </a:r>
                     </a:p>
                   </a:txBody>
@@ -5033,7 +5618,53 @@
                 </a:tc>
                 <a:tc>
                   <a:txBody>
-                    <a:bodyPr wrap="none" lIns="38100" rIns="38100" tIns="25400" bIns="25400"/>
+                    <a:bodyPr wrap="none" lIns="50800" rIns="50800" tIns="25400" bIns="25400"/>
+                    <a:lstStyle/>
+                    <a:p>
+                      <a:pPr algn="l"/>
+                      <a:r>
+                        <a:rPr sz="850" b="0">
+                          <a:solidFill>
+                            <a:srgbClr val="1A1A2E"/>
+                          </a:solidFill>
+                          <a:latin typeface="Calibri"/>
+                        </a:rPr>
+                        <a:t>HTTP agent</a:t>
+                      </a:r>
+                    </a:p>
+                  </a:txBody>
+                  <a:tcPr>
+                    <a:solidFill>
+                      <a:srgbClr val="F5F8FC"/>
+                    </a:solidFill>
+                  </a:tcPr>
+                </a:tc>
+                <a:tc>
+                  <a:txBody>
+                    <a:bodyPr wrap="none" lIns="50800" rIns="50800" tIns="25400" bIns="25400"/>
+                    <a:lstStyle/>
+                    <a:p>
+                      <a:pPr algn="l"/>
+                      <a:r>
+                        <a:rPr sz="850" b="0">
+                          <a:solidFill>
+                            <a:srgbClr val="1A1A2E"/>
+                          </a:solidFill>
+                          <a:latin typeface="Calibri"/>
+                        </a:rPr>
+                        <a:t>API 心跳</a:t>
+                      </a:r>
+                    </a:p>
+                  </a:txBody>
+                  <a:tcPr>
+                    <a:solidFill>
+                      <a:srgbClr val="F5F8FC"/>
+                    </a:solidFill>
+                  </a:tcPr>
+                </a:tc>
+                <a:tc>
+                  <a:txBody>
+                    <a:bodyPr wrap="none" lIns="50800" rIns="50800" tIns="25400" bIns="25400"/>
                     <a:lstStyle/>
                     <a:p>
                       <a:pPr algn="ctr"/>
@@ -5056,7 +5687,7 @@
                 </a:tc>
                 <a:tc>
                   <a:txBody>
-                    <a:bodyPr wrap="none" lIns="38100" rIns="38100" tIns="25400" bIns="25400"/>
+                    <a:bodyPr wrap="none" lIns="50800" rIns="50800" tIns="25400" bIns="25400"/>
                     <a:lstStyle/>
                     <a:p>
                       <a:pPr algn="ctr"/>
@@ -5079,7 +5710,7 @@
                 </a:tc>
                 <a:tc>
                   <a:txBody>
-                    <a:bodyPr wrap="none" lIns="38100" rIns="38100" tIns="25400" bIns="25400"/>
+                    <a:bodyPr wrap="none" lIns="50800" rIns="50800" tIns="25400" bIns="25400"/>
                     <a:lstStyle/>
                     <a:p>
                       <a:pPr algn="ctr"/>
@@ -5102,18 +5733,18 @@
                 </a:tc>
                 <a:tc>
                   <a:txBody>
-                    <a:bodyPr wrap="none" lIns="38100" rIns="38100" tIns="25400" bIns="25400"/>
+                    <a:bodyPr wrap="none" lIns="50800" rIns="50800" tIns="25400" bIns="25400"/>
                     <a:lstStyle/>
                     <a:p>
                       <a:pPr algn="ctr"/>
                       <a:r>
                         <a:rPr sz="850" b="0">
                           <a:solidFill>
-                            <a:srgbClr val="55657A"/>
-                          </a:solidFill>
-                          <a:latin typeface="Calibri"/>
-                        </a:rPr>
-                        <a:t>—</a:t>
+                            <a:srgbClr val="1A8A4A"/>
+                          </a:solidFill>
+                          <a:latin typeface="Calibri"/>
+                        </a:rPr>
+                        <a:t>✓</a:t>
                       </a:r>
                     </a:p>
                   </a:txBody>
@@ -5123,699 +5754,20 @@
                     </a:solidFill>
                   </a:tcPr>
                 </a:tc>
-              </a:tr>
-              <a:tr h="292608">
-                <a:tc>
-                  <a:txBody>
-                    <a:bodyPr wrap="none" lIns="38100" rIns="38100" tIns="25400" bIns="25400"/>
-                    <a:lstStyle/>
-                    <a:p>
-                      <a:pPr algn="ctr"/>
-                      <a:r>
-                        <a:rPr sz="850" b="1">
-                          <a:solidFill>
-                            <a:srgbClr val="FFFFFF"/>
-                          </a:solidFill>
-                          <a:latin typeface="Calibri"/>
-                        </a:rPr>
-                        <a:t>LAND</a:t>
-                      </a:r>
-                    </a:p>
-                  </a:txBody>
-                  <a:tcPr>
-                    <a:solidFill>
-                      <a:srgbClr val="1A3A6B"/>
-                    </a:solidFill>
-                  </a:tcPr>
-                </a:tc>
-                <a:tc>
-                  <a:txBody>
-                    <a:bodyPr wrap="none" lIns="38100" rIns="38100" tIns="25400" bIns="25400"/>
-                    <a:lstStyle/>
-                    <a:p>
-                      <a:pPr algn="ctr"/>
+                <a:tc>
+                  <a:txBody>
+                    <a:bodyPr wrap="none" lIns="50800" rIns="50800" tIns="25400" bIns="25400"/>
+                    <a:lstStyle/>
+                    <a:p>
+                      <a:pPr algn="l"/>
                       <a:r>
                         <a:rPr sz="850" b="0">
                           <a:solidFill>
-                            <a:srgbClr val="1A8A4A"/>
-                          </a:solidFill>
-                          <a:latin typeface="Calibri"/>
-                        </a:rPr>
-                        <a:t>✓</a:t>
-                      </a:r>
-                    </a:p>
-                  </a:txBody>
-                  <a:tcPr>
-                    <a:solidFill>
-                      <a:srgbClr val="EBF3FB"/>
-                    </a:solidFill>
-                  </a:tcPr>
-                </a:tc>
-                <a:tc>
-                  <a:txBody>
-                    <a:bodyPr wrap="none" lIns="38100" rIns="38100" tIns="25400" bIns="25400"/>
-                    <a:lstStyle/>
-                    <a:p>
-                      <a:pPr algn="ctr"/>
-                      <a:r>
-                        <a:rPr sz="850" b="0">
-                          <a:solidFill>
-                            <a:srgbClr val="1A8A4A"/>
-                          </a:solidFill>
-                          <a:latin typeface="Calibri"/>
-                        </a:rPr>
-                        <a:t>✓</a:t>
-                      </a:r>
-                    </a:p>
-                  </a:txBody>
-                  <a:tcPr>
-                    <a:solidFill>
-                      <a:srgbClr val="EBF3FB"/>
-                    </a:solidFill>
-                  </a:tcPr>
-                </a:tc>
-                <a:tc>
-                  <a:txBody>
-                    <a:bodyPr wrap="none" lIns="38100" rIns="38100" tIns="25400" bIns="25400"/>
-                    <a:lstStyle/>
-                    <a:p>
-                      <a:pPr algn="ctr"/>
-                      <a:r>
-                        <a:rPr sz="850" b="0">
-                          <a:solidFill>
-                            <a:srgbClr val="1A8A4A"/>
-                          </a:solidFill>
-                          <a:latin typeface="Calibri"/>
-                        </a:rPr>
-                        <a:t>✓</a:t>
-                      </a:r>
-                    </a:p>
-                  </a:txBody>
-                  <a:tcPr>
-                    <a:solidFill>
-                      <a:srgbClr val="EBF3FB"/>
-                    </a:solidFill>
-                  </a:tcPr>
-                </a:tc>
-                <a:tc>
-                  <a:txBody>
-                    <a:bodyPr wrap="none" lIns="38100" rIns="38100" tIns="25400" bIns="25400"/>
-                    <a:lstStyle/>
-                    <a:p>
-                      <a:pPr algn="ctr"/>
-                      <a:r>
-                        <a:rPr sz="850" b="0">
-                          <a:solidFill>
-                            <a:srgbClr val="1A8A4A"/>
-                          </a:solidFill>
-                          <a:latin typeface="Calibri"/>
-                        </a:rPr>
-                        <a:t>✓</a:t>
-                      </a:r>
-                    </a:p>
-                  </a:txBody>
-                  <a:tcPr>
-                    <a:solidFill>
-                      <a:srgbClr val="EBF3FB"/>
-                    </a:solidFill>
-                  </a:tcPr>
-                </a:tc>
-              </a:tr>
-              <a:tr h="292608">
-                <a:tc>
-                  <a:txBody>
-                    <a:bodyPr wrap="none" lIns="38100" rIns="38100" tIns="25400" bIns="25400"/>
-                    <a:lstStyle/>
-                    <a:p>
-                      <a:pPr algn="ctr"/>
-                      <a:r>
-                        <a:rPr sz="850" b="1">
-                          <a:solidFill>
-                            <a:srgbClr val="FFFFFF"/>
-                          </a:solidFill>
-                          <a:latin typeface="Calibri"/>
-                        </a:rPr>
-                        <a:t>LANH</a:t>
-                      </a:r>
-                    </a:p>
-                  </a:txBody>
-                  <a:tcPr>
-                    <a:solidFill>
-                      <a:srgbClr val="1A3A6B"/>
-                    </a:solidFill>
-                  </a:tcPr>
-                </a:tc>
-                <a:tc>
-                  <a:txBody>
-                    <a:bodyPr wrap="none" lIns="38100" rIns="38100" tIns="25400" bIns="25400"/>
-                    <a:lstStyle/>
-                    <a:p>
-                      <a:pPr algn="ctr"/>
-                      <a:r>
-                        <a:rPr sz="850" b="0">
-                          <a:solidFill>
-                            <a:srgbClr val="1A8A4A"/>
-                          </a:solidFill>
-                          <a:latin typeface="Calibri"/>
-                        </a:rPr>
-                        <a:t>✓</a:t>
-                      </a:r>
-                    </a:p>
-                  </a:txBody>
-                  <a:tcPr>
-                    <a:solidFill>
-                      <a:srgbClr val="F5F8FC"/>
-                    </a:solidFill>
-                  </a:tcPr>
-                </a:tc>
-                <a:tc>
-                  <a:txBody>
-                    <a:bodyPr wrap="none" lIns="38100" rIns="38100" tIns="25400" bIns="25400"/>
-                    <a:lstStyle/>
-                    <a:p>
-                      <a:pPr algn="ctr"/>
-                      <a:r>
-                        <a:rPr sz="850" b="0">
-                          <a:solidFill>
-                            <a:srgbClr val="55657A"/>
-                          </a:solidFill>
-                          <a:latin typeface="Calibri"/>
-                        </a:rPr>
-                        <a:t>—</a:t>
-                      </a:r>
-                    </a:p>
-                  </a:txBody>
-                  <a:tcPr>
-                    <a:solidFill>
-                      <a:srgbClr val="F5F8FC"/>
-                    </a:solidFill>
-                  </a:tcPr>
-                </a:tc>
-                <a:tc>
-                  <a:txBody>
-                    <a:bodyPr wrap="none" lIns="38100" rIns="38100" tIns="25400" bIns="25400"/>
-                    <a:lstStyle/>
-                    <a:p>
-                      <a:pPr algn="ctr"/>
-                      <a:r>
-                        <a:rPr sz="850" b="0">
-                          <a:solidFill>
-                            <a:srgbClr val="55657A"/>
-                          </a:solidFill>
-                          <a:latin typeface="Calibri"/>
-                        </a:rPr>
-                        <a:t>—</a:t>
-                      </a:r>
-                    </a:p>
-                  </a:txBody>
-                  <a:tcPr>
-                    <a:solidFill>
-                      <a:srgbClr val="F5F8FC"/>
-                    </a:solidFill>
-                  </a:tcPr>
-                </a:tc>
-                <a:tc>
-                  <a:txBody>
-                    <a:bodyPr wrap="none" lIns="38100" rIns="38100" tIns="25400" bIns="25400"/>
-                    <a:lstStyle/>
-                    <a:p>
-                      <a:pPr algn="ctr"/>
-                      <a:r>
-                        <a:rPr sz="850" b="0">
-                          <a:solidFill>
-                            <a:srgbClr val="1A8A4A"/>
-                          </a:solidFill>
-                          <a:latin typeface="Calibri"/>
-                        </a:rPr>
-                        <a:t>✓</a:t>
-                      </a:r>
-                    </a:p>
-                  </a:txBody>
-                  <a:tcPr>
-                    <a:solidFill>
-                      <a:srgbClr val="F5F8FC"/>
-                    </a:solidFill>
-                  </a:tcPr>
-                </a:tc>
-              </a:tr>
-              <a:tr h="292608">
-                <a:tc>
-                  <a:txBody>
-                    <a:bodyPr wrap="none" lIns="38100" rIns="38100" tIns="25400" bIns="25400"/>
-                    <a:lstStyle/>
-                    <a:p>
-                      <a:pPr algn="ctr"/>
-                      <a:r>
-                        <a:rPr sz="850" b="1">
-                          <a:solidFill>
-                            <a:srgbClr val="FFFFFF"/>
-                          </a:solidFill>
-                          <a:latin typeface="Calibri"/>
-                        </a:rPr>
-                        <a:t>SINEXCEL</a:t>
-                      </a:r>
-                    </a:p>
-                  </a:txBody>
-                  <a:tcPr>
-                    <a:solidFill>
-                      <a:srgbClr val="1A3A6B"/>
-                    </a:solidFill>
-                  </a:tcPr>
-                </a:tc>
-                <a:tc>
-                  <a:txBody>
-                    <a:bodyPr wrap="none" lIns="38100" rIns="38100" tIns="25400" bIns="25400"/>
-                    <a:lstStyle/>
-                    <a:p>
-                      <a:pPr algn="ctr"/>
-                      <a:r>
-                        <a:rPr sz="850" b="0">
-                          <a:solidFill>
-                            <a:srgbClr val="1A8A4A"/>
-                          </a:solidFill>
-                          <a:latin typeface="Calibri"/>
-                        </a:rPr>
-                        <a:t>✓</a:t>
-                      </a:r>
-                    </a:p>
-                  </a:txBody>
-                  <a:tcPr>
-                    <a:solidFill>
-                      <a:srgbClr val="EBF3FB"/>
-                    </a:solidFill>
-                  </a:tcPr>
-                </a:tc>
-                <a:tc>
-                  <a:txBody>
-                    <a:bodyPr wrap="none" lIns="38100" rIns="38100" tIns="25400" bIns="25400"/>
-                    <a:lstStyle/>
-                    <a:p>
-                      <a:pPr algn="ctr"/>
-                      <a:r>
-                        <a:rPr sz="850" b="0">
-                          <a:solidFill>
-                            <a:srgbClr val="1A8A4A"/>
-                          </a:solidFill>
-                          <a:latin typeface="Calibri"/>
-                        </a:rPr>
-                        <a:t>✓</a:t>
-                      </a:r>
-                    </a:p>
-                  </a:txBody>
-                  <a:tcPr>
-                    <a:solidFill>
-                      <a:srgbClr val="EBF3FB"/>
-                    </a:solidFill>
-                  </a:tcPr>
-                </a:tc>
-                <a:tc>
-                  <a:txBody>
-                    <a:bodyPr wrap="none" lIns="38100" rIns="38100" tIns="25400" bIns="25400"/>
-                    <a:lstStyle/>
-                    <a:p>
-                      <a:pPr algn="ctr"/>
-                      <a:r>
-                        <a:rPr sz="850" b="0">
-                          <a:solidFill>
-                            <a:srgbClr val="1A8A4A"/>
-                          </a:solidFill>
-                          <a:latin typeface="Calibri"/>
-                        </a:rPr>
-                        <a:t>✓</a:t>
-                      </a:r>
-                    </a:p>
-                  </a:txBody>
-                  <a:tcPr>
-                    <a:solidFill>
-                      <a:srgbClr val="EBF3FB"/>
-                    </a:solidFill>
-                  </a:tcPr>
-                </a:tc>
-                <a:tc>
-                  <a:txBody>
-                    <a:bodyPr wrap="none" lIns="38100" rIns="38100" tIns="25400" bIns="25400"/>
-                    <a:lstStyle/>
-                    <a:p>
-                      <a:pPr algn="ctr"/>
-                      <a:r>
-                        <a:rPr sz="850" b="0">
-                          <a:solidFill>
-                            <a:srgbClr val="1A8A4A"/>
-                          </a:solidFill>
-                          <a:latin typeface="Calibri"/>
-                        </a:rPr>
-                        <a:t>✓</a:t>
-                      </a:r>
-                    </a:p>
-                  </a:txBody>
-                  <a:tcPr>
-                    <a:solidFill>
-                      <a:srgbClr val="EBF3FB"/>
-                    </a:solidFill>
-                  </a:tcPr>
-                </a:tc>
-              </a:tr>
-              <a:tr h="292608">
-                <a:tc>
-                  <a:txBody>
-                    <a:bodyPr wrap="none" lIns="38100" rIns="38100" tIns="25400" bIns="25400"/>
-                    <a:lstStyle/>
-                    <a:p>
-                      <a:pPr algn="ctr"/>
-                      <a:r>
-                        <a:rPr sz="850" b="1">
-                          <a:solidFill>
-                            <a:srgbClr val="FFFFFF"/>
-                          </a:solidFill>
-                          <a:latin typeface="Calibri"/>
-                        </a:rPr>
-                        <a:t>NBT</a:t>
-                      </a:r>
-                    </a:p>
-                  </a:txBody>
-                  <a:tcPr>
-                    <a:solidFill>
-                      <a:srgbClr val="1A3A6B"/>
-                    </a:solidFill>
-                  </a:tcPr>
-                </a:tc>
-                <a:tc>
-                  <a:txBody>
-                    <a:bodyPr wrap="none" lIns="38100" rIns="38100" tIns="25400" bIns="25400"/>
-                    <a:lstStyle/>
-                    <a:p>
-                      <a:pPr algn="ctr"/>
-                      <a:r>
-                        <a:rPr sz="850" b="0">
-                          <a:solidFill>
-                            <a:srgbClr val="1A8A4A"/>
-                          </a:solidFill>
-                          <a:latin typeface="Calibri"/>
-                        </a:rPr>
-                        <a:t>✓</a:t>
-                      </a:r>
-                    </a:p>
-                  </a:txBody>
-                  <a:tcPr>
-                    <a:solidFill>
-                      <a:srgbClr val="F5F8FC"/>
-                    </a:solidFill>
-                  </a:tcPr>
-                </a:tc>
-                <a:tc>
-                  <a:txBody>
-                    <a:bodyPr wrap="none" lIns="38100" rIns="38100" tIns="25400" bIns="25400"/>
-                    <a:lstStyle/>
-                    <a:p>
-                      <a:pPr algn="ctr"/>
-                      <a:r>
-                        <a:rPr sz="850" b="0">
-                          <a:solidFill>
-                            <a:srgbClr val="1A8A4A"/>
-                          </a:solidFill>
-                          <a:latin typeface="Calibri"/>
-                        </a:rPr>
-                        <a:t>✓</a:t>
-                      </a:r>
-                    </a:p>
-                  </a:txBody>
-                  <a:tcPr>
-                    <a:solidFill>
-                      <a:srgbClr val="F5F8FC"/>
-                    </a:solidFill>
-                  </a:tcPr>
-                </a:tc>
-                <a:tc>
-                  <a:txBody>
-                    <a:bodyPr wrap="none" lIns="38100" rIns="38100" tIns="25400" bIns="25400"/>
-                    <a:lstStyle/>
-                    <a:p>
-                      <a:pPr algn="ctr"/>
-                      <a:r>
-                        <a:rPr sz="850" b="0">
-                          <a:solidFill>
-                            <a:srgbClr val="1A8A4A"/>
-                          </a:solidFill>
-                          <a:latin typeface="Calibri"/>
-                        </a:rPr>
-                        <a:t>✓</a:t>
-                      </a:r>
-                    </a:p>
-                  </a:txBody>
-                  <a:tcPr>
-                    <a:solidFill>
-                      <a:srgbClr val="F5F8FC"/>
-                    </a:solidFill>
-                  </a:tcPr>
-                </a:tc>
-                <a:tc>
-                  <a:txBody>
-                    <a:bodyPr wrap="none" lIns="38100" rIns="38100" tIns="25400" bIns="25400"/>
-                    <a:lstStyle/>
-                    <a:p>
-                      <a:pPr algn="ctr"/>
-                      <a:r>
-                        <a:rPr sz="850" b="0">
-                          <a:solidFill>
-                            <a:srgbClr val="1A8A4A"/>
-                          </a:solidFill>
-                          <a:latin typeface="Calibri"/>
-                        </a:rPr>
-                        <a:t>✓</a:t>
-                      </a:r>
-                    </a:p>
-                  </a:txBody>
-                  <a:tcPr>
-                    <a:solidFill>
-                      <a:srgbClr val="F5F8FC"/>
-                    </a:solidFill>
-                  </a:tcPr>
-                </a:tc>
-              </a:tr>
-              <a:tr h="292608">
-                <a:tc>
-                  <a:txBody>
-                    <a:bodyPr wrap="none" lIns="38100" rIns="38100" tIns="25400" bIns="25400"/>
-                    <a:lstStyle/>
-                    <a:p>
-                      <a:pPr algn="ctr"/>
-                      <a:r>
-                        <a:rPr sz="850" b="1">
-                          <a:solidFill>
-                            <a:srgbClr val="FFFFFF"/>
-                          </a:solidFill>
-                          <a:latin typeface="Calibri"/>
-                        </a:rPr>
-                        <a:t>DAHUA</a:t>
-                      </a:r>
-                    </a:p>
-                  </a:txBody>
-                  <a:tcPr>
-                    <a:solidFill>
-                      <a:srgbClr val="1A3A6B"/>
-                    </a:solidFill>
-                  </a:tcPr>
-                </a:tc>
-                <a:tc>
-                  <a:txBody>
-                    <a:bodyPr wrap="none" lIns="38100" rIns="38100" tIns="25400" bIns="25400"/>
-                    <a:lstStyle/>
-                    <a:p>
-                      <a:pPr algn="ctr"/>
-                      <a:r>
-                        <a:rPr sz="850" b="0">
-                          <a:solidFill>
-                            <a:srgbClr val="55657A"/>
-                          </a:solidFill>
-                          <a:latin typeface="Calibri"/>
-                        </a:rPr>
-                        <a:t>—</a:t>
-                      </a:r>
-                    </a:p>
-                  </a:txBody>
-                  <a:tcPr>
-                    <a:solidFill>
-                      <a:srgbClr val="EBF3FB"/>
-                    </a:solidFill>
-                  </a:tcPr>
-                </a:tc>
-                <a:tc>
-                  <a:txBody>
-                    <a:bodyPr wrap="none" lIns="38100" rIns="38100" tIns="25400" bIns="25400"/>
-                    <a:lstStyle/>
-                    <a:p>
-                      <a:pPr algn="ctr"/>
-                      <a:r>
-                        <a:rPr sz="850" b="0">
-                          <a:solidFill>
-                            <a:srgbClr val="55657A"/>
-                          </a:solidFill>
-                          <a:latin typeface="Calibri"/>
-                        </a:rPr>
-                        <a:t>—</a:t>
-                      </a:r>
-                    </a:p>
-                  </a:txBody>
-                  <a:tcPr>
-                    <a:solidFill>
-                      <a:srgbClr val="EBF3FB"/>
-                    </a:solidFill>
-                  </a:tcPr>
-                </a:tc>
-                <a:tc>
-                  <a:txBody>
-                    <a:bodyPr wrap="none" lIns="38100" rIns="38100" tIns="25400" bIns="25400"/>
-                    <a:lstStyle/>
-                    <a:p>
-                      <a:pPr algn="ctr"/>
-                      <a:r>
-                        <a:rPr sz="850" b="0">
-                          <a:solidFill>
-                            <a:srgbClr val="55657A"/>
-                          </a:solidFill>
-                          <a:latin typeface="Calibri"/>
-                        </a:rPr>
-                        <a:t>—</a:t>
-                      </a:r>
-                    </a:p>
-                  </a:txBody>
-                  <a:tcPr>
-                    <a:solidFill>
-                      <a:srgbClr val="EBF3FB"/>
-                    </a:solidFill>
-                  </a:tcPr>
-                </a:tc>
-                <a:tc>
-                  <a:txBody>
-                    <a:bodyPr wrap="none" lIns="38100" rIns="38100" tIns="25400" bIns="25400"/>
-                    <a:lstStyle/>
-                    <a:p>
-                      <a:pPr algn="ctr"/>
-                      <a:r>
-                        <a:rPr sz="850" b="0">
-                          <a:solidFill>
-                            <a:srgbClr val="1A8A4A"/>
-                          </a:solidFill>
-                          <a:latin typeface="Calibri"/>
-                        </a:rPr>
-                        <a:t>✓</a:t>
-                      </a:r>
-                    </a:p>
-                  </a:txBody>
-                  <a:tcPr>
-                    <a:solidFill>
-                      <a:srgbClr val="EBF3FB"/>
-                    </a:solidFill>
-                  </a:tcPr>
-                </a:tc>
-              </a:tr>
-              <a:tr h="292608">
-                <a:tc>
-                  <a:txBody>
-                    <a:bodyPr wrap="none" lIns="38100" rIns="38100" tIns="25400" bIns="25400"/>
-                    <a:lstStyle/>
-                    <a:p>
-                      <a:pPr algn="ctr"/>
-                      <a:r>
-                        <a:rPr sz="850" b="1">
-                          <a:solidFill>
-                            <a:srgbClr val="FFFFFF"/>
-                          </a:solidFill>
-                          <a:latin typeface="Calibri"/>
-                        </a:rPr>
-                        <a:t>JHAI</a:t>
-                      </a:r>
-                    </a:p>
-                  </a:txBody>
-                  <a:tcPr>
-                    <a:solidFill>
-                      <a:srgbClr val="1A3A6B"/>
-                    </a:solidFill>
-                  </a:tcPr>
-                </a:tc>
-                <a:tc>
-                  <a:txBody>
-                    <a:bodyPr wrap="none" lIns="38100" rIns="38100" tIns="25400" bIns="25400"/>
-                    <a:lstStyle/>
-                    <a:p>
-                      <a:pPr algn="ctr"/>
-                      <a:r>
-                        <a:rPr sz="850" b="0">
-                          <a:solidFill>
-                            <a:srgbClr val="1A8A4A"/>
-                          </a:solidFill>
-                          <a:latin typeface="Calibri"/>
-                        </a:rPr>
-                        <a:t>✓</a:t>
-                      </a:r>
-                    </a:p>
-                  </a:txBody>
-                  <a:tcPr>
-                    <a:solidFill>
-                      <a:srgbClr val="F5F8FC"/>
-                    </a:solidFill>
-                  </a:tcPr>
-                </a:tc>
-                <a:tc>
-                  <a:txBody>
-                    <a:bodyPr wrap="none" lIns="38100" rIns="38100" tIns="25400" bIns="25400"/>
-                    <a:lstStyle/>
-                    <a:p>
-                      <a:pPr algn="ctr"/>
-                      <a:r>
-                        <a:rPr sz="850" b="0">
-                          <a:solidFill>
-                            <a:srgbClr val="1A8A4A"/>
-                          </a:solidFill>
-                          <a:latin typeface="Calibri"/>
-                        </a:rPr>
-                        <a:t>✓</a:t>
-                      </a:r>
-                    </a:p>
-                  </a:txBody>
-                  <a:tcPr>
-                    <a:solidFill>
-                      <a:srgbClr val="F5F8FC"/>
-                    </a:solidFill>
-                  </a:tcPr>
-                </a:tc>
-                <a:tc>
-                  <a:txBody>
-                    <a:bodyPr wrap="none" lIns="38100" rIns="38100" tIns="25400" bIns="25400"/>
-                    <a:lstStyle/>
-                    <a:p>
-                      <a:pPr algn="ctr"/>
-                      <a:r>
-                        <a:rPr sz="850" b="0">
-                          <a:solidFill>
-                            <a:srgbClr val="1A8A4A"/>
-                          </a:solidFill>
-                          <a:latin typeface="Calibri"/>
-                        </a:rPr>
-                        <a:t>✓</a:t>
-                      </a:r>
-                    </a:p>
-                  </a:txBody>
-                  <a:tcPr>
-                    <a:solidFill>
-                      <a:srgbClr val="F5F8FC"/>
-                    </a:solidFill>
-                  </a:tcPr>
-                </a:tc>
-                <a:tc>
-                  <a:txBody>
-                    <a:bodyPr wrap="none" lIns="38100" rIns="38100" tIns="25400" bIns="25400"/>
-                    <a:lstStyle/>
-                    <a:p>
-                      <a:pPr algn="ctr"/>
-                      <a:r>
-                        <a:rPr sz="850" b="0">
-                          <a:solidFill>
-                            <a:srgbClr val="1A8A4A"/>
-                          </a:solidFill>
-                          <a:latin typeface="Calibri"/>
-                        </a:rPr>
-                        <a:t>✓</a:t>
+                            <a:srgbClr val="1A1A2E"/>
+                          </a:solidFill>
+                          <a:latin typeface="Calibri"/>
+                        </a:rPr>
+                        <a:t>API Resend</a:t>
                       </a:r>
                     </a:p>
                   </a:txBody>
@@ -5833,446 +5785,6 @@
       <p:sp>
         <p:nvSpPr>
           <p:cNvPr id="26" name="Rectangle 25"/>
-          <p:cNvSpPr/>
-          <p:nvPr/>
-        </p:nvSpPr>
-        <p:spPr>
-          <a:xfrm>
-            <a:off x="6178143" y="3685032"/>
-            <a:ext cx="5848959" cy="256032"/>
-          </a:xfrm>
-          <a:prstGeom prst="rect">
-            <a:avLst/>
-          </a:prstGeom>
-          <a:solidFill>
-            <a:srgbClr val="275EA6"/>
-          </a:solidFill>
-          <a:ln w="6350">
-            <a:noFill/>
-          </a:ln>
-        </p:spPr>
-        <p:style>
-          <a:lnRef idx="1">
-            <a:schemeClr val="accent1"/>
-          </a:lnRef>
-          <a:fillRef idx="3">
-            <a:schemeClr val="accent1"/>
-          </a:fillRef>
-          <a:effectRef idx="2">
-            <a:schemeClr val="accent1"/>
-          </a:effectRef>
-          <a:fontRef idx="minor">
-            <a:schemeClr val="lt1"/>
-          </a:fontRef>
-        </p:style>
-        <p:txBody>
-          <a:bodyPr rtlCol="0" anchor="ctr"/>
-          <a:lstStyle/>
-          <a:p>
-            <a:pPr algn="ctr"/>
-          </a:p>
-        </p:txBody>
-      </p:sp>
-      <p:sp>
-        <p:nvSpPr>
-          <p:cNvPr id="27" name="TextBox 26"/>
-          <p:cNvSpPr txBox="1"/>
-          <p:nvPr/>
-        </p:nvSpPr>
-        <p:spPr>
-          <a:xfrm>
-            <a:off x="6269583" y="3703320"/>
-            <a:ext cx="5666079" cy="219456"/>
-          </a:xfrm>
-          <a:prstGeom prst="rect">
-            <a:avLst/>
-          </a:prstGeom>
-          <a:noFill/>
-        </p:spPr>
-        <p:txBody>
-          <a:bodyPr wrap="square" lIns="25400" rIns="25400" tIns="12700" bIns="12700">
-            <a:spAutoFit/>
-          </a:bodyPr>
-          <a:lstStyle/>
-          <a:p>
-            <a:pPr algn="l"/>
-            <a:r>
-              <a:rPr sz="1000" b="1" i="0">
-                <a:solidFill>
-                  <a:srgbClr val="FFFFFF"/>
-                </a:solidFill>
-                <a:latin typeface="Calibri"/>
-              </a:rPr>
-              <a:t>🚀  近期关键改进</a:t>
-            </a:r>
-          </a:p>
-        </p:txBody>
-      </p:sp>
-      <p:graphicFrame>
-        <p:nvGraphicFramePr>
-          <p:cNvPr id="28" name="Table 27"/>
-          <p:cNvGraphicFramePr>
-            <a:graphicFrameLocks noGrp="1"/>
-          </p:cNvGraphicFramePr>
-          <p:nvPr/>
-        </p:nvGraphicFramePr>
-        <p:xfrm>
-          <a:off x="6178143" y="3968496"/>
-          <a:ext cx="5848959" cy="2340863"/>
-        </p:xfrm>
-        <a:graphic>
-          <a:graphicData uri="http://schemas.openxmlformats.org/drawingml/2006/table">
-            <a:tbl>
-              <a:tblPr firstRow="1" bandRow="1">
-                <a:tableStyleId>{5C22544A-7EE6-4342-B048-85BDC9FD1C3A}</a:tableStyleId>
-              </a:tblPr>
-              <a:tblGrid>
-                <a:gridCol w="1691640"/>
-                <a:gridCol w="4157319"/>
-              </a:tblGrid>
-              <a:tr h="334409">
-                <a:tc>
-                  <a:txBody>
-                    <a:bodyPr wrap="none" lIns="38100" rIns="38100" tIns="25400" bIns="25400"/>
-                    <a:lstStyle/>
-                    <a:p>
-                      <a:pPr algn="l"/>
-                      <a:r>
-                        <a:rPr sz="800" b="1">
-                          <a:solidFill>
-                            <a:srgbClr val="FFFFFF"/>
-                          </a:solidFill>
-                          <a:latin typeface="Calibri"/>
-                        </a:rPr>
-                        <a:t>标题</a:t>
-                      </a:r>
-                    </a:p>
-                  </a:txBody>
-                  <a:tcPr>
-                    <a:solidFill>
-                      <a:srgbClr val="275EA6"/>
-                    </a:solidFill>
-                  </a:tcPr>
-                </a:tc>
-                <a:tc>
-                  <a:txBody>
-                    <a:bodyPr wrap="none" lIns="38100" rIns="38100" tIns="25400" bIns="25400"/>
-                    <a:lstStyle/>
-                    <a:p>
-                      <a:pPr algn="l"/>
-                      <a:r>
-                        <a:rPr sz="800" b="1">
-                          <a:solidFill>
-                            <a:srgbClr val="FFFFFF"/>
-                          </a:solidFill>
-                          <a:latin typeface="Calibri"/>
-                        </a:rPr>
-                        <a:t>说明</a:t>
-                      </a:r>
-                    </a:p>
-                  </a:txBody>
-                  <a:tcPr>
-                    <a:solidFill>
-                      <a:srgbClr val="275EA6"/>
-                    </a:solidFill>
-                  </a:tcPr>
-                </a:tc>
-              </a:tr>
-              <a:tr h="334409">
-                <a:tc>
-                  <a:txBody>
-                    <a:bodyPr wrap="none" lIns="38100" rIns="38100" tIns="25400" bIns="25400"/>
-                    <a:lstStyle/>
-                    <a:p>
-                      <a:pPr algn="l"/>
-                      <a:r>
-                        <a:rPr sz="800" b="1">
-                          <a:solidFill>
-                            <a:srgbClr val="1A3A6B"/>
-                          </a:solidFill>
-                          <a:latin typeface="Calibri"/>
-                        </a:rPr>
-                        <a:t>strategy: free · forks=50</a:t>
-                      </a:r>
-                    </a:p>
-                  </a:txBody>
-                  <a:tcPr>
-                    <a:solidFill>
-                      <a:srgbClr val="F5F8FC"/>
-                    </a:solidFill>
-                  </a:tcPr>
-                </a:tc>
-                <a:tc>
-                  <a:txBody>
-                    <a:bodyPr wrap="none" lIns="38100" rIns="38100" tIns="25400" bIns="25400"/>
-                    <a:lstStyle/>
-                    <a:p>
-                      <a:pPr algn="l"/>
-                      <a:r>
-                        <a:rPr sz="800" b="0">
-                          <a:solidFill>
-                            <a:srgbClr val="1A1A2E"/>
-                          </a:solidFill>
-                          <a:latin typeface="Calibri"/>
-                        </a:rPr>
-                        <a:t>批量并行化，单台 WinRM 挂起不再阻塞整批设备</a:t>
-                      </a:r>
-                    </a:p>
-                  </a:txBody>
-                  <a:tcPr>
-                    <a:solidFill>
-                      <a:srgbClr val="F5F8FC"/>
-                    </a:solidFill>
-                  </a:tcPr>
-                </a:tc>
-              </a:tr>
-              <a:tr h="334409">
-                <a:tc>
-                  <a:txBody>
-                    <a:bodyPr wrap="none" lIns="38100" rIns="38100" tIns="25400" bIns="25400"/>
-                    <a:lstStyle/>
-                    <a:p>
-                      <a:pPr algn="l"/>
-                      <a:r>
-                        <a:rPr sz="800" b="1">
-                          <a:solidFill>
-                            <a:srgbClr val="1A3A6B"/>
-                          </a:solidFill>
-                          <a:latin typeface="Calibri"/>
-                        </a:rPr>
-                        <a:t>LANH QueryStatus API</a:t>
-                      </a:r>
-                    </a:p>
-                  </a:txBody>
-                  <a:tcPr>
-                    <a:solidFill>
-                      <a:srgbClr val="EBF3FB"/>
-                    </a:solidFill>
-                  </a:tcPr>
-                </a:tc>
-                <a:tc>
-                  <a:txBody>
-                    <a:bodyPr wrap="none" lIns="38100" rIns="38100" tIns="25400" bIns="25400"/>
-                    <a:lstStyle/>
-                    <a:p>
-                      <a:pPr algn="l"/>
-                      <a:r>
-                        <a:rPr sz="800" b="0">
-                          <a:solidFill>
-                            <a:srgbClr val="1A1A2E"/>
-                          </a:solidFill>
-                          <a:latin typeface="Calibri"/>
-                        </a:rPr>
-                        <a:t>Patrol / check_restart 接入 SyncLims，与 LAND 同流程</a:t>
-                      </a:r>
-                    </a:p>
-                  </a:txBody>
-                  <a:tcPr>
-                    <a:solidFill>
-                      <a:srgbClr val="EBF3FB"/>
-                    </a:solidFill>
-                  </a:tcPr>
-                </a:tc>
-              </a:tr>
-              <a:tr h="334409">
-                <a:tc>
-                  <a:txBody>
-                    <a:bodyPr wrap="none" lIns="38100" rIns="38100" tIns="25400" bIns="25400"/>
-                    <a:lstStyle/>
-                    <a:p>
-                      <a:pPr algn="l"/>
-                      <a:r>
-                        <a:rPr sz="800" b="1">
-                          <a:solidFill>
-                            <a:srgbClr val="1A3A6B"/>
-                          </a:solidFill>
-                          <a:latin typeface="Calibri"/>
-                        </a:rPr>
-                        <a:t>任务日志新标签页</a:t>
-                      </a:r>
-                    </a:p>
-                  </a:txBody>
-                  <a:tcPr>
-                    <a:solidFill>
-                      <a:srgbClr val="F5F8FC"/>
-                    </a:solidFill>
-                  </a:tcPr>
-                </a:tc>
-                <a:tc>
-                  <a:txBody>
-                    <a:bodyPr wrap="none" lIns="38100" rIns="38100" tIns="25400" bIns="25400"/>
-                    <a:lstStyle/>
-                    <a:p>
-                      <a:pPr algn="l"/>
-                      <a:r>
-                        <a:rPr sz="800" b="0">
-                          <a:solidFill>
-                            <a:srgbClr val="1A1A2E"/>
-                          </a:solidFill>
-                          <a:latin typeface="Calibri"/>
-                        </a:rPr>
-                        <a:t>点击任务链接在新浏览器标签页打开，不遮挡设备列表</a:t>
-                      </a:r>
-                    </a:p>
-                  </a:txBody>
-                  <a:tcPr>
-                    <a:solidFill>
-                      <a:srgbClr val="F5F8FC"/>
-                    </a:solidFill>
-                  </a:tcPr>
-                </a:tc>
-              </a:tr>
-              <a:tr h="334409">
-                <a:tc>
-                  <a:txBody>
-                    <a:bodyPr wrap="none" lIns="38100" rIns="38100" tIns="25400" bIns="25400"/>
-                    <a:lstStyle/>
-                    <a:p>
-                      <a:pPr algn="l"/>
-                      <a:r>
-                        <a:rPr sz="800" b="1">
-                          <a:solidFill>
-                            <a:srgbClr val="1A3A6B"/>
-                          </a:solidFill>
-                          <a:latin typeface="Calibri"/>
-                        </a:rPr>
-                        <a:t>DAHUA -mtime-prefilter</a:t>
-                      </a:r>
-                    </a:p>
-                  </a:txBody>
-                  <a:tcPr>
-                    <a:solidFill>
-                      <a:srgbClr val="EBF3FB"/>
-                    </a:solidFill>
-                  </a:tcPr>
-                </a:tc>
-                <a:tc>
-                  <a:txBody>
-                    <a:bodyPr wrap="none" lIns="38100" rIns="38100" tIns="25400" bIns="25400"/>
-                    <a:lstStyle/>
-                    <a:p>
-                      <a:pPr algn="l"/>
-                      <a:r>
-                        <a:rPr sz="800" b="0">
-                          <a:solidFill>
-                            <a:srgbClr val="1A1A2E"/>
-                          </a:solidFill>
-                          <a:latin typeface="Calibri"/>
-                        </a:rPr>
-                        <a:t>lims-hist 默认追加，大幅提升重发扫描效率</a:t>
-                      </a:r>
-                    </a:p>
-                  </a:txBody>
-                  <a:tcPr>
-                    <a:solidFill>
-                      <a:srgbClr val="EBF3FB"/>
-                    </a:solidFill>
-                  </a:tcPr>
-                </a:tc>
-              </a:tr>
-              <a:tr h="334409">
-                <a:tc>
-                  <a:txBody>
-                    <a:bodyPr wrap="none" lIns="38100" rIns="38100" tIns="25400" bIns="25400"/>
-                    <a:lstStyle/>
-                    <a:p>
-                      <a:pPr algn="l"/>
-                      <a:r>
-                        <a:rPr sz="800" b="1">
-                          <a:solidFill>
-                            <a:srgbClr val="1A3A6B"/>
-                          </a:solidFill>
-                          <a:latin typeface="Calibri"/>
-                        </a:rPr>
-                        <a:t>Kafka TCP 超时修复</a:t>
-                      </a:r>
-                    </a:p>
-                  </a:txBody>
-                  <a:tcPr>
-                    <a:solidFill>
-                      <a:srgbClr val="F5F8FC"/>
-                    </a:solidFill>
-                  </a:tcPr>
-                </a:tc>
-                <a:tc>
-                  <a:txBody>
-                    <a:bodyPr wrap="none" lIns="38100" rIns="38100" tIns="25400" bIns="25400"/>
-                    <a:lstStyle/>
-                    <a:p>
-                      <a:pPr algn="l"/>
-                      <a:r>
-                        <a:rPr sz="800" b="0">
-                          <a:solidFill>
-                            <a:srgbClr val="1A1A2E"/>
-                          </a:solidFill>
-                          <a:latin typeface="Calibri"/>
-                        </a:rPr>
-                        <a:t>NEWARE 探测超时从数小时缩至秒级，不再阻塞 check_restart</a:t>
-                      </a:r>
-                    </a:p>
-                  </a:txBody>
-                  <a:tcPr>
-                    <a:solidFill>
-                      <a:srgbClr val="F5F8FC"/>
-                    </a:solidFill>
-                  </a:tcPr>
-                </a:tc>
-              </a:tr>
-              <a:tr h="334409">
-                <a:tc>
-                  <a:txBody>
-                    <a:bodyPr wrap="none" lIns="38100" rIns="38100" tIns="25400" bIns="25400"/>
-                    <a:lstStyle/>
-                    <a:p>
-                      <a:pPr algn="l"/>
-                      <a:r>
-                        <a:rPr sz="800" b="1">
-                          <a:solidFill>
-                            <a:srgbClr val="1A3A6B"/>
-                          </a:solidFill>
-                          <a:latin typeface="Calibri"/>
-                        </a:rPr>
-                        <a:t>WinRM Top 5 进程诊断</a:t>
-                      </a:r>
-                    </a:p>
-                  </a:txBody>
-                  <a:tcPr>
-                    <a:solidFill>
-                      <a:srgbClr val="EBF3FB"/>
-                    </a:solidFill>
-                  </a:tcPr>
-                </a:tc>
-                <a:tc>
-                  <a:txBody>
-                    <a:bodyPr wrap="none" lIns="38100" rIns="38100" tIns="25400" bIns="25400"/>
-                    <a:lstStyle/>
-                    <a:p>
-                      <a:pPr algn="l"/>
-                      <a:r>
-                        <a:rPr sz="800" b="0">
-                          <a:solidFill>
-                            <a:srgbClr val="1A1A2E"/>
-                          </a:solidFill>
-                          <a:latin typeface="Calibri"/>
-                        </a:rPr>
-                        <a:t>内置 CPU / 内存占用 Top 5，辅助现场排障</a:t>
-                      </a:r>
-                    </a:p>
-                  </a:txBody>
-                  <a:tcPr>
-                    <a:solidFill>
-                      <a:srgbClr val="EBF3FB"/>
-                    </a:solidFill>
-                  </a:tcPr>
-                </a:tc>
-              </a:tr>
-            </a:tbl>
-          </a:graphicData>
-        </a:graphic>
-      </p:graphicFrame>
-      <p:sp>
-        <p:nvSpPr>
-          <p:cNvPr id="29" name="Rectangle 28"/>
           <p:cNvSpPr/>
           <p:nvPr/>
         </p:nvSpPr>
@@ -6315,7 +5827,7 @@
       </p:sp>
       <p:sp>
         <p:nvSpPr>
-          <p:cNvPr id="30" name="TextBox 29"/>
+          <p:cNvPr id="27" name="TextBox 26"/>
           <p:cNvSpPr txBox="1"/>
           <p:nvPr/>
         </p:nvSpPr>
@@ -6343,7 +5855,7 @@
                 </a:solidFill>
                 <a:latin typeface="Calibri"/>
               </a:rPr>
-              <a:t>30 Playbooks  ·  38 Shared Tasks  ·  9 PowerShell Helpers  ·  当前 UI：巡检 / 重发 / 重启 / 重部署  ·  2026-08</a:t>
+              <a:t>二次开发相对原始 Semaphore  ·  7 设备类型  ·  当前 UI：巡检 / 重发 / 重启 / 重部署  ·  2026-08</a:t>
             </a:r>
           </a:p>
         </p:txBody>

</xml_diff>